<commit_message>
Pitch deck: add speaker notes + Sources/Appendix slide
- Speaker notes on all 13 slides (presenter talking points)
- New "Sources & notes" appendix slide listing each stat with the primary
  source to cite, plus a verify-before-use disclaimer
- Deck is now 13 slides, 13 notes, 3 charts

Co-Authored-By: Claude Opus 4.8 <noreply@anthropic.com>
</commit_message>
<xml_diff>
--- a/ParkEase-Pitch-Deck.pptx
+++ b/ParkEase-Pitch-Deck.pptx
@@ -17,9 +17,10 @@
     <p:sldId id="265" r:id="rId11"/>
     <p:sldId id="266" r:id="rId12"/>
     <p:sldId id="267" r:id="rId13"/>
+    <p:sldId id="268" r:id="rId14"/>
   </p:sldIdLst>
   <p:notesMasterIdLst>
-    <p:notesMasterId r:id="rId14"/>
+    <p:notesMasterId r:id="rId15"/>
   </p:notesMasterIdLst>
   <p:sldSz cx="9144000" cy="5143500"/>
   <p:notesSz cx="5143500" cy="9144000"/>
@@ -1423,7 +1424,7 @@
           <a:p>
             <a:r>
               <a:rPr lang="en-US" dirty="0"/>
-              <a:t/>
+              <a:t>Open with energy. ParkEase is a smart-parking platform that lets drivers find and reserve a guaranteed spot before they arrive. Frame it as solving a daily, universal pain in Indian cities — then move quickly into the problem.</a:t>
             </a:r>
             <a:endParaRPr lang="en-US" dirty="0"/>
           </a:p>
@@ -1511,7 +1512,7 @@
           <a:p>
             <a:r>
               <a:rPr lang="en-US" dirty="0"/>
-              <a:t/>
+              <a:t>Explain the economics: commission per booking is the core revenue, plus owner subscriptions and featured listings, a share of dynamic/surge pricing, and partnerships (EV, insurance). Multiple streams, asset-light.</a:t>
             </a:r>
             <a:endParaRPr lang="en-US" dirty="0"/>
           </a:p>
@@ -1599,7 +1600,7 @@
           <a:p>
             <a:r>
               <a:rPr lang="en-US" dirty="0"/>
-              <a:t/>
+              <a:t>Summarise the edge — aggregation + real-time + secure payments + monitoring + AI in a single product — then paint the roadmap: AI availability prediction, dynamic pricing, EV/IoT integration, native mobile apps and city partnerships.</a:t>
             </a:r>
             <a:endParaRPr lang="en-US" dirty="0"/>
           </a:p>
@@ -1687,7 +1688,7 @@
           <a:p>
             <a:r>
               <a:rPr lang="en-US" dirty="0"/>
-              <a:t/>
+              <a:t>End on the vision and a clear ask. 'Park with certainty, arrive with ease.' State exactly what you're seeking — a pilot, a partnership, mentorship, or funding — and invite questions.</a:t>
             </a:r>
             <a:endParaRPr lang="en-US" dirty="0"/>
           </a:p>
@@ -1711,6 +1712,94 @@
             <a:fld id="{F7021451-1387-4CA6-816F-3879F97B5CBC}" type="slidenum">
               <a:rPr lang="en-US"/>
               <a:t>12</a:t>
+            </a:fld>
+            <a:endParaRPr lang="en-US"/>
+          </a:p>
+        </p:txBody>
+      </p:sp>
+    </p:spTree>
+    <p:extLst>
+      <p:ext uri="{BB962C8B-B14F-4D97-AF65-F5344CB8AC3E}">
+        <p14:creationId xmlns:p14="http://schemas.microsoft.com/office/powerpoint/2010/main" val="1024086991"/>
+      </p:ext>
+    </p:extLst>
+  </p:cSld>
+  <p:clrMapOvr>
+    <a:masterClrMapping/>
+  </p:clrMapOvr>
+</p:notes>
+</file>
+
+<file path=ppt/notesSlides/notesSlide13.xml><?xml version="1.0" encoding="utf-8"?>
+<p:notes xmlns:a="http://schemas.openxmlformats.org/drawingml/2006/main" xmlns:r="http://schemas.openxmlformats.org/officeDocument/2006/relationships" xmlns:p="http://schemas.openxmlformats.org/presentationml/2006/main">
+  <p:cSld>
+    <p:spTree>
+      <p:nvGrpSpPr>
+        <p:cNvPr id="1" name=""/>
+        <p:cNvGrpSpPr/>
+        <p:nvPr/>
+      </p:nvGrpSpPr>
+      <p:grpSpPr>
+        <a:xfrm>
+          <a:off x="0" y="0"/>
+          <a:ext cx="0" cy="0"/>
+          <a:chOff x="0" y="0"/>
+          <a:chExt cx="0" cy="0"/>
+        </a:xfrm>
+      </p:grpSpPr>
+      <p:sp>
+        <p:nvSpPr>
+          <p:cNvPr id="2" name="Slide Image Placeholder 1"/>
+          <p:cNvSpPr>
+            <a:spLocks noGrp="1" noRot="1" noChangeAspect="1"/>
+          </p:cNvSpPr>
+          <p:nvPr>
+            <p:ph type="sldImg"/>
+          </p:nvPr>
+        </p:nvSpPr>
+        <p:spPr/>
+      </p:sp>
+      <p:sp>
+        <p:nvSpPr>
+          <p:cNvPr id="3" name="Notes Placeholder 2"/>
+          <p:cNvSpPr>
+            <a:spLocks noGrp="1"/>
+          </p:cNvSpPr>
+          <p:nvPr>
+            <p:ph type="body" idx="1"/>
+          </p:nvPr>
+        </p:nvSpPr>
+        <p:spPr/>
+        <p:txBody>
+          <a:bodyPr/>
+          <a:lstStyle/>
+          <a:p>
+            <a:r>
+              <a:rPr lang="en-US" dirty="0"/>
+              <a:t>Backup/appendix slide. Use it to answer 'where did these numbers come from?'. Replace each placeholder with the exact primary citation (with year and link) before you present.</a:t>
+            </a:r>
+            <a:endParaRPr lang="en-US" dirty="0"/>
+          </a:p>
+        </p:txBody>
+      </p:sp>
+      <p:sp>
+        <p:nvSpPr>
+          <p:cNvPr id="4" name="Slide Number Placeholder 3"/>
+          <p:cNvSpPr>
+            <a:spLocks noGrp="1"/>
+          </p:cNvSpPr>
+          <p:nvPr>
+            <p:ph type="sldNum" sz="quarter" idx="10"/>
+          </p:nvPr>
+        </p:nvSpPr>
+        <p:spPr/>
+        <p:txBody>
+          <a:bodyPr/>
+          <a:lstStyle/>
+          <a:p>
+            <a:fld id="{F7021451-1387-4CA6-816F-3879F97B5CBC}" type="slidenum">
+              <a:rPr lang="en-US"/>
+              <a:t>13</a:t>
             </a:fld>
             <a:endParaRPr lang="en-US"/>
           </a:p>
@@ -1775,7 +1864,7 @@
           <a:p>
             <a:r>
               <a:rPr lang="en-US" dirty="0"/>
-              <a:t/>
+              <a:t>Set the scene: vehicle ownership is booming but parking information hasn't kept up. Drivers waste 15–20 minutes per trip and often park illegally out of desperation. Land the emotional hook before showing the hard numbers.</a:t>
             </a:r>
             <a:endParaRPr lang="en-US" dirty="0"/>
           </a:p>
@@ -1863,7 +1952,7 @@
           <a:p>
             <a:r>
               <a:rPr lang="en-US" dirty="0"/>
-              <a:t/>
+              <a:t>Hit the headline stats hard, pausing after each. 8 crore+ traffic challans a year nationally; Noida alone issued ~2.7 lakh illegal-parking challans in a single year; Delhi issues ~65,000 a month — roughly 7.8 lakh a year. Note: cite official/press sources (see the appendix) before presenting.</a:t>
             </a:r>
             <a:endParaRPr lang="en-US" dirty="0"/>
           </a:p>
@@ -1951,7 +2040,7 @@
           <a:p>
             <a:r>
               <a:rPr lang="en-US" dirty="0"/>
-              <a:t/>
+              <a:t>Reframe the cost. It isn't just the fine — parking search drives an estimated ~30% of urban congestion, wastes fuel and raises emissions. Make it a societal problem, not just an individual inconvenience.</a:t>
             </a:r>
             <a:endParaRPr lang="en-US" dirty="0"/>
           </a:p>
@@ -2039,7 +2128,7 @@
           <a:p>
             <a:r>
               <a:rPr lang="en-US" dirty="0"/>
-              <a:t/>
+              <a:t>Introduce ParkEase as the fix: one live map aggregating commercial lots, street and private spaces. Two sides of the marketplace — drivers reserve and pay ahead; owners monetise space they already own. Emphasise it's asset-light.</a:t>
             </a:r>
             <a:endParaRPr lang="en-US" dirty="0"/>
           </a:p>
@@ -2127,7 +2216,7 @@
           <a:p>
             <a:r>
               <a:rPr lang="en-US" dirty="0"/>
-              <a:t/>
+              <a:t>Walk the simple four-step flow and stress it takes under a minute with a guaranteed spot. Real-time availability over WebSockets means what the driver sees is actually free right now.</a:t>
             </a:r>
             <a:endParaRPr lang="en-US" dirty="0"/>
           </a:p>
@@ -2215,7 +2304,7 @@
           <a:p>
             <a:r>
               <a:rPr lang="en-US" dirty="0"/>
-              <a:t/>
+              <a:t>Stress that this is a working, full-stack platform — not a mockup. Call out the differentiators: real payments via Razorpay, live monitoring with Park.Guard, verified (booking-gated) reviews, and the built-in AI assistant.</a:t>
             </a:r>
             <a:endParaRPr lang="en-US" dirty="0"/>
           </a:p>
@@ -2303,7 +2392,7 @@
           <a:p>
             <a:r>
               <a:rPr lang="en-US" dirty="0"/>
-              <a:t/>
+              <a:t>Quantify the upside. ~17 minutes saved per trip; at 1M users and two trips a day that's roughly 570,000 driver-hours saved every day. Fewer cars circling means fewer illegal-parking fines and less congestion. Flag the chart as an illustrative model.</a:t>
             </a:r>
             <a:endParaRPr lang="en-US" dirty="0"/>
           </a:p>
@@ -2391,7 +2480,7 @@
           <a:p>
             <a:r>
               <a:rPr lang="en-US" dirty="0"/>
-              <a:t/>
+              <a:t>Size the prize: 350M+ registered vehicles, 500M+ urban residents, and rising smartphone/UPI adoption. Even a small share is a large business. Flag the growth curve as illustrative — swap in a sourced market report for fundraising.</a:t>
             </a:r>
             <a:endParaRPr lang="en-US" dirty="0"/>
           </a:p>
@@ -3263,7 +3352,7 @@
       </p:sp>
       <p:graphicFrame>
         <p:nvGraphicFramePr>
-          <p:cNvPr id="7" name="Chart 0" descr=""/>
+          <p:cNvPr id="8" name="Chart 0" descr=""/>
           <p:cNvGraphicFramePr/>
           <p:nvPr/>
         </p:nvGraphicFramePr>
@@ -4032,6 +4121,892 @@
 </p:sld>
 </file>
 
+<file path=ppt/slides/slide13.xml><?xml version="1.0" encoding="utf-8"?>
+<p:sld xmlns:a="http://schemas.openxmlformats.org/drawingml/2006/main" xmlns:r="http://schemas.openxmlformats.org/officeDocument/2006/relationships" xmlns:p="http://schemas.openxmlformats.org/presentationml/2006/main">
+  <p:cSld name="Slide 13">
+    <p:bg>
+      <p:bgPr>
+        <a:solidFill>
+          <a:srgbClr val="0A0A12"/>
+        </a:solidFill>
+      </p:bgPr>
+    </p:bg>
+    <p:spTree>
+      <p:nvGrpSpPr>
+        <p:cNvPr id="1" name=""/>
+        <p:cNvGrpSpPr/>
+        <p:nvPr/>
+      </p:nvGrpSpPr>
+      <p:grpSpPr>
+        <a:xfrm>
+          <a:off x="0" y="0"/>
+          <a:ext cx="0" cy="0"/>
+          <a:chOff x="0" y="0"/>
+          <a:chExt cx="0" cy="0"/>
+        </a:xfrm>
+      </p:grpSpPr>
+      <p:sp>
+        <p:nvSpPr>
+          <p:cNvPr id="2" name="Text 0"/>
+          <p:cNvSpPr/>
+          <p:nvPr/>
+        </p:nvSpPr>
+        <p:spPr>
+          <a:xfrm>
+            <a:off x="507950" y="381000"/>
+            <a:ext cx="8290661" cy="152400"/>
+          </a:xfrm>
+          <a:prstGeom prst="rect">
+            <a:avLst/>
+          </a:prstGeom>
+          <a:noFill/>
+          <a:ln/>
+        </p:spPr>
+        <p:txBody>
+          <a:bodyPr wrap="square" lIns="0" tIns="0" rIns="0" bIns="0" rtlCol="0" anchor="t"/>
+          <a:lstStyle/>
+          <a:p>
+            <a:pPr algn="l" indent="0" marL="0">
+              <a:buNone/>
+            </a:pPr>
+            <a:r>
+              <a:rPr lang="en-US" sz="1100" b="1" dirty="0">
+                <a:solidFill>
+                  <a:srgbClr val="C084FC"/>
+                </a:solidFill>
+                <a:latin typeface="Arial" pitchFamily="34" charset="0"/>
+                <a:ea typeface="Arial" pitchFamily="34" charset="-122"/>
+                <a:cs typeface="Arial" pitchFamily="34" charset="-120"/>
+              </a:rPr>
+              <a:t>APPENDIX</a:t>
+            </a:r>
+            <a:endParaRPr lang="en-US" sz="1100" dirty="0"/>
+          </a:p>
+        </p:txBody>
+      </p:sp>
+      <p:sp>
+        <p:nvSpPr>
+          <p:cNvPr id="3" name="Text 1"/>
+          <p:cNvSpPr/>
+          <p:nvPr/>
+        </p:nvSpPr>
+        <p:spPr>
+          <a:xfrm>
+            <a:off x="507950" y="634901"/>
+            <a:ext cx="8290661" cy="400050"/>
+          </a:xfrm>
+          <a:prstGeom prst="rect">
+            <a:avLst/>
+          </a:prstGeom>
+          <a:noFill/>
+          <a:ln/>
+        </p:spPr>
+        <p:txBody>
+          <a:bodyPr wrap="square" lIns="0" tIns="0" rIns="0" bIns="0" rtlCol="0" anchor="t"/>
+          <a:lstStyle/>
+          <a:p>
+            <a:pPr algn="l" indent="0" marL="0">
+              <a:spcBef>
+                <a:spcPts val="800"/>
+              </a:spcBef>
+              <a:buNone/>
+            </a:pPr>
+            <a:r>
+              <a:rPr lang="en-US" sz="2700" b="1" dirty="0">
+                <a:solidFill>
+                  <a:srgbClr val="FFFFFF"/>
+                </a:solidFill>
+                <a:latin typeface="Arial" pitchFamily="34" charset="0"/>
+                <a:ea typeface="Arial" pitchFamily="34" charset="-122"/>
+                <a:cs typeface="Arial" pitchFamily="34" charset="-120"/>
+              </a:rPr>
+              <a:t>Sources &amp; notes.</a:t>
+            </a:r>
+            <a:endParaRPr lang="en-US" sz="2700" dirty="0"/>
+          </a:p>
+        </p:txBody>
+      </p:sp>
+      <p:pic>
+        <p:nvPicPr>
+          <p:cNvPr id="4" name="Image 0" descr="/Users/yashwantyadav/Desktop/Parking_assist/deck-build/assets/gradbar.png">    </p:cNvPr>
+          <p:cNvPicPr>
+            <a:picLocks noChangeAspect="1"/>
+          </p:cNvPicPr>
+          <p:nvPr/>
+        </p:nvPicPr>
+        <p:blipFill>
+          <a:blip r:embed="rId1"/>
+          <a:stretch>
+            <a:fillRect/>
+          </a:stretch>
+        </p:blipFill>
+        <p:spPr>
+          <a:xfrm>
+            <a:off x="507950" y="1161901"/>
+            <a:ext cx="1143000" cy="63401"/>
+          </a:xfrm>
+          <a:prstGeom prst="rect">
+            <a:avLst/>
+          </a:prstGeom>
+        </p:spPr>
+      </p:pic>
+      <p:sp>
+        <p:nvSpPr>
+          <p:cNvPr id="5" name="Shape 2"/>
+          <p:cNvSpPr/>
+          <p:nvPr/>
+        </p:nvSpPr>
+        <p:spPr>
+          <a:xfrm>
+            <a:off x="507950" y="1737866"/>
+            <a:ext cx="8128099" cy="0"/>
+          </a:xfrm>
+          <a:prstGeom prst="line">
+            <a:avLst/>
+          </a:prstGeom>
+          <a:noFill/>
+          <a:ln w="9525">
+            <a:solidFill>
+              <a:srgbClr val="211F30"/>
+            </a:solidFill>
+            <a:prstDash val="solid"/>
+          </a:ln>
+        </p:spPr>
+      </p:sp>
+      <p:sp>
+        <p:nvSpPr>
+          <p:cNvPr id="6" name="Text 3"/>
+          <p:cNvSpPr/>
+          <p:nvPr/>
+        </p:nvSpPr>
+        <p:spPr>
+          <a:xfrm>
+            <a:off x="507950" y="1491853"/>
+            <a:ext cx="4274820" cy="152400"/>
+          </a:xfrm>
+          <a:prstGeom prst="rect">
+            <a:avLst/>
+          </a:prstGeom>
+          <a:noFill/>
+          <a:ln/>
+        </p:spPr>
+        <p:txBody>
+          <a:bodyPr wrap="square" lIns="0" tIns="0" rIns="0" bIns="0" rtlCol="0" anchor="t"/>
+          <a:lstStyle/>
+          <a:p>
+            <a:pPr algn="l" indent="0" marL="0">
+              <a:buNone/>
+            </a:pPr>
+            <a:r>
+              <a:rPr lang="en-US" sz="1050" dirty="0">
+                <a:solidFill>
+                  <a:srgbClr val="D3D4DE"/>
+                </a:solidFill>
+                <a:latin typeface="Arial" pitchFamily="34" charset="0"/>
+                <a:ea typeface="Arial" pitchFamily="34" charset="-122"/>
+                <a:cs typeface="Arial" pitchFamily="34" charset="-120"/>
+              </a:rPr>
+              <a:t>8 Cr+ traffic challans / year (India)</a:t>
+            </a:r>
+            <a:endParaRPr lang="en-US" sz="1050" dirty="0"/>
+          </a:p>
+        </p:txBody>
+      </p:sp>
+      <p:sp>
+        <p:nvSpPr>
+          <p:cNvPr id="7" name="Text 4"/>
+          <p:cNvSpPr/>
+          <p:nvPr/>
+        </p:nvSpPr>
+        <p:spPr>
+          <a:xfrm>
+            <a:off x="5008980" y="1491853"/>
+            <a:ext cx="3627069" cy="152400"/>
+          </a:xfrm>
+          <a:prstGeom prst="rect">
+            <a:avLst/>
+          </a:prstGeom>
+          <a:noFill/>
+          <a:ln/>
+        </p:spPr>
+        <p:txBody>
+          <a:bodyPr wrap="square" lIns="0" tIns="0" rIns="0" bIns="0" rtlCol="0" anchor="t"/>
+          <a:lstStyle/>
+          <a:p>
+            <a:pPr algn="r" indent="0" marL="0">
+              <a:buNone/>
+            </a:pPr>
+            <a:r>
+              <a:rPr lang="en-US" sz="1000" dirty="0">
+                <a:solidFill>
+                  <a:srgbClr val="8B8FA6"/>
+                </a:solidFill>
+                <a:latin typeface="Arial" pitchFamily="34" charset="0"/>
+                <a:ea typeface="Arial" pitchFamily="34" charset="-122"/>
+                <a:cs typeface="Arial" pitchFamily="34" charset="-120"/>
+              </a:rPr>
+              <a:t>NCRB / MoRTH / national press reports</a:t>
+            </a:r>
+            <a:endParaRPr lang="en-US" sz="1000" dirty="0"/>
+          </a:p>
+        </p:txBody>
+      </p:sp>
+      <p:sp>
+        <p:nvSpPr>
+          <p:cNvPr id="8" name="Shape 5"/>
+          <p:cNvSpPr/>
+          <p:nvPr/>
+        </p:nvSpPr>
+        <p:spPr>
+          <a:xfrm>
+            <a:off x="507950" y="2077492"/>
+            <a:ext cx="8128099" cy="0"/>
+          </a:xfrm>
+          <a:prstGeom prst="line">
+            <a:avLst/>
+          </a:prstGeom>
+          <a:noFill/>
+          <a:ln w="9525">
+            <a:solidFill>
+              <a:srgbClr val="211F30"/>
+            </a:solidFill>
+            <a:prstDash val="solid"/>
+          </a:ln>
+        </p:spPr>
+      </p:sp>
+      <p:sp>
+        <p:nvSpPr>
+          <p:cNvPr id="9" name="Text 6"/>
+          <p:cNvSpPr/>
+          <p:nvPr/>
+        </p:nvSpPr>
+        <p:spPr>
+          <a:xfrm>
+            <a:off x="507950" y="1831479"/>
+            <a:ext cx="4274820" cy="152400"/>
+          </a:xfrm>
+          <a:prstGeom prst="rect">
+            <a:avLst/>
+          </a:prstGeom>
+          <a:noFill/>
+          <a:ln/>
+        </p:spPr>
+        <p:txBody>
+          <a:bodyPr wrap="square" lIns="0" tIns="0" rIns="0" bIns="0" rtlCol="0" anchor="t"/>
+          <a:lstStyle/>
+          <a:p>
+            <a:pPr algn="l" indent="0" marL="0">
+              <a:buNone/>
+            </a:pPr>
+            <a:r>
+              <a:rPr lang="en-US" sz="1050" dirty="0">
+                <a:solidFill>
+                  <a:srgbClr val="D3D4DE"/>
+                </a:solidFill>
+                <a:latin typeface="Arial" pitchFamily="34" charset="0"/>
+                <a:ea typeface="Arial" pitchFamily="34" charset="-122"/>
+                <a:cs typeface="Arial" pitchFamily="34" charset="-120"/>
+              </a:rPr>
+              <a:t>2.7 lakh illegal-parking challans, Noida (1 year)</a:t>
+            </a:r>
+            <a:endParaRPr lang="en-US" sz="1050" dirty="0"/>
+          </a:p>
+        </p:txBody>
+      </p:sp>
+      <p:sp>
+        <p:nvSpPr>
+          <p:cNvPr id="10" name="Text 7"/>
+          <p:cNvSpPr/>
+          <p:nvPr/>
+        </p:nvSpPr>
+        <p:spPr>
+          <a:xfrm>
+            <a:off x="5008980" y="1831479"/>
+            <a:ext cx="3627069" cy="152400"/>
+          </a:xfrm>
+          <a:prstGeom prst="rect">
+            <a:avLst/>
+          </a:prstGeom>
+          <a:noFill/>
+          <a:ln/>
+        </p:spPr>
+        <p:txBody>
+          <a:bodyPr wrap="square" lIns="0" tIns="0" rIns="0" bIns="0" rtlCol="0" anchor="t"/>
+          <a:lstStyle/>
+          <a:p>
+            <a:pPr algn="r" indent="0" marL="0">
+              <a:buNone/>
+            </a:pPr>
+            <a:r>
+              <a:rPr lang="en-US" sz="1000" dirty="0">
+                <a:solidFill>
+                  <a:srgbClr val="8B8FA6"/>
+                </a:solidFill>
+                <a:latin typeface="Arial" pitchFamily="34" charset="0"/>
+                <a:ea typeface="Arial" pitchFamily="34" charset="-122"/>
+                <a:cs typeface="Arial" pitchFamily="34" charset="-120"/>
+              </a:rPr>
+              <a:t>Noida Traffic Police / press reports</a:t>
+            </a:r>
+            <a:endParaRPr lang="en-US" sz="1000" dirty="0"/>
+          </a:p>
+        </p:txBody>
+      </p:sp>
+      <p:sp>
+        <p:nvSpPr>
+          <p:cNvPr id="11" name="Shape 8"/>
+          <p:cNvSpPr/>
+          <p:nvPr/>
+        </p:nvSpPr>
+        <p:spPr>
+          <a:xfrm>
+            <a:off x="507950" y="2417118"/>
+            <a:ext cx="8128099" cy="0"/>
+          </a:xfrm>
+          <a:prstGeom prst="line">
+            <a:avLst/>
+          </a:prstGeom>
+          <a:noFill/>
+          <a:ln w="9525">
+            <a:solidFill>
+              <a:srgbClr val="211F30"/>
+            </a:solidFill>
+            <a:prstDash val="solid"/>
+          </a:ln>
+        </p:spPr>
+      </p:sp>
+      <p:sp>
+        <p:nvSpPr>
+          <p:cNvPr id="12" name="Text 9"/>
+          <p:cNvSpPr/>
+          <p:nvPr/>
+        </p:nvSpPr>
+        <p:spPr>
+          <a:xfrm>
+            <a:off x="507950" y="2171105"/>
+            <a:ext cx="4274820" cy="152400"/>
+          </a:xfrm>
+          <a:prstGeom prst="rect">
+            <a:avLst/>
+          </a:prstGeom>
+          <a:noFill/>
+          <a:ln/>
+        </p:spPr>
+        <p:txBody>
+          <a:bodyPr wrap="square" lIns="0" tIns="0" rIns="0" bIns="0" rtlCol="0" anchor="t"/>
+          <a:lstStyle/>
+          <a:p>
+            <a:pPr algn="l" indent="0" marL="0">
+              <a:buNone/>
+            </a:pPr>
+            <a:r>
+              <a:rPr lang="en-US" sz="1050" dirty="0">
+                <a:solidFill>
+                  <a:srgbClr val="D3D4DE"/>
+                </a:solidFill>
+                <a:latin typeface="Arial" pitchFamily="34" charset="0"/>
+                <a:ea typeface="Arial" pitchFamily="34" charset="-122"/>
+                <a:cs typeface="Arial" pitchFamily="34" charset="-120"/>
+              </a:rPr>
+              <a:t>~65,000 illegal-parking challans / month, Delhi</a:t>
+            </a:r>
+            <a:endParaRPr lang="en-US" sz="1050" dirty="0"/>
+          </a:p>
+        </p:txBody>
+      </p:sp>
+      <p:sp>
+        <p:nvSpPr>
+          <p:cNvPr id="13" name="Text 10"/>
+          <p:cNvSpPr/>
+          <p:nvPr/>
+        </p:nvSpPr>
+        <p:spPr>
+          <a:xfrm>
+            <a:off x="5008980" y="2171105"/>
+            <a:ext cx="3627069" cy="152400"/>
+          </a:xfrm>
+          <a:prstGeom prst="rect">
+            <a:avLst/>
+          </a:prstGeom>
+          <a:noFill/>
+          <a:ln/>
+        </p:spPr>
+        <p:txBody>
+          <a:bodyPr wrap="square" lIns="0" tIns="0" rIns="0" bIns="0" rtlCol="0" anchor="t"/>
+          <a:lstStyle/>
+          <a:p>
+            <a:pPr algn="r" indent="0" marL="0">
+              <a:buNone/>
+            </a:pPr>
+            <a:r>
+              <a:rPr lang="en-US" sz="1000" dirty="0">
+                <a:solidFill>
+                  <a:srgbClr val="8B8FA6"/>
+                </a:solidFill>
+                <a:latin typeface="Arial" pitchFamily="34" charset="0"/>
+                <a:ea typeface="Arial" pitchFamily="34" charset="-122"/>
+                <a:cs typeface="Arial" pitchFamily="34" charset="-120"/>
+              </a:rPr>
+              <a:t>Delhi Traffic Police / press reports</a:t>
+            </a:r>
+            <a:endParaRPr lang="en-US" sz="1000" dirty="0"/>
+          </a:p>
+        </p:txBody>
+      </p:sp>
+      <p:sp>
+        <p:nvSpPr>
+          <p:cNvPr id="14" name="Shape 11"/>
+          <p:cNvSpPr/>
+          <p:nvPr/>
+        </p:nvSpPr>
+        <p:spPr>
+          <a:xfrm>
+            <a:off x="507950" y="2756743"/>
+            <a:ext cx="8128099" cy="0"/>
+          </a:xfrm>
+          <a:prstGeom prst="line">
+            <a:avLst/>
+          </a:prstGeom>
+          <a:noFill/>
+          <a:ln w="9525">
+            <a:solidFill>
+              <a:srgbClr val="211F30"/>
+            </a:solidFill>
+            <a:prstDash val="solid"/>
+          </a:ln>
+        </p:spPr>
+      </p:sp>
+      <p:sp>
+        <p:nvSpPr>
+          <p:cNvPr id="15" name="Text 12"/>
+          <p:cNvSpPr/>
+          <p:nvPr/>
+        </p:nvSpPr>
+        <p:spPr>
+          <a:xfrm>
+            <a:off x="507950" y="2510730"/>
+            <a:ext cx="4274820" cy="152400"/>
+          </a:xfrm>
+          <a:prstGeom prst="rect">
+            <a:avLst/>
+          </a:prstGeom>
+          <a:noFill/>
+          <a:ln/>
+        </p:spPr>
+        <p:txBody>
+          <a:bodyPr wrap="square" lIns="0" tIns="0" rIns="0" bIns="0" rtlCol="0" anchor="t"/>
+          <a:lstStyle/>
+          <a:p>
+            <a:pPr algn="l" indent="0" marL="0">
+              <a:buNone/>
+            </a:pPr>
+            <a:r>
+              <a:rPr lang="en-US" sz="1050" dirty="0">
+                <a:solidFill>
+                  <a:srgbClr val="D3D4DE"/>
+                </a:solidFill>
+                <a:latin typeface="Arial" pitchFamily="34" charset="0"/>
+                <a:ea typeface="Arial" pitchFamily="34" charset="-122"/>
+                <a:cs typeface="Arial" pitchFamily="34" charset="-120"/>
+              </a:rPr>
+              <a:t>350M+ registered vehicles in India</a:t>
+            </a:r>
+            <a:endParaRPr lang="en-US" sz="1050" dirty="0"/>
+          </a:p>
+        </p:txBody>
+      </p:sp>
+      <p:sp>
+        <p:nvSpPr>
+          <p:cNvPr id="16" name="Text 13"/>
+          <p:cNvSpPr/>
+          <p:nvPr/>
+        </p:nvSpPr>
+        <p:spPr>
+          <a:xfrm>
+            <a:off x="5008980" y="2510730"/>
+            <a:ext cx="3627069" cy="152400"/>
+          </a:xfrm>
+          <a:prstGeom prst="rect">
+            <a:avLst/>
+          </a:prstGeom>
+          <a:noFill/>
+          <a:ln/>
+        </p:spPr>
+        <p:txBody>
+          <a:bodyPr wrap="square" lIns="0" tIns="0" rIns="0" bIns="0" rtlCol="0" anchor="t"/>
+          <a:lstStyle/>
+          <a:p>
+            <a:pPr algn="r" indent="0" marL="0">
+              <a:buNone/>
+            </a:pPr>
+            <a:r>
+              <a:rPr lang="en-US" sz="1000" dirty="0">
+                <a:solidFill>
+                  <a:srgbClr val="8B8FA6"/>
+                </a:solidFill>
+                <a:latin typeface="Arial" pitchFamily="34" charset="0"/>
+                <a:ea typeface="Arial" pitchFamily="34" charset="-122"/>
+                <a:cs typeface="Arial" pitchFamily="34" charset="-120"/>
+              </a:rPr>
+              <a:t>MoRTH “Vahan” / Road Transport Yearbook</a:t>
+            </a:r>
+            <a:endParaRPr lang="en-US" sz="1000" dirty="0"/>
+          </a:p>
+        </p:txBody>
+      </p:sp>
+      <p:sp>
+        <p:nvSpPr>
+          <p:cNvPr id="17" name="Shape 14"/>
+          <p:cNvSpPr/>
+          <p:nvPr/>
+        </p:nvSpPr>
+        <p:spPr>
+          <a:xfrm>
+            <a:off x="507950" y="3096369"/>
+            <a:ext cx="8128099" cy="0"/>
+          </a:xfrm>
+          <a:prstGeom prst="line">
+            <a:avLst/>
+          </a:prstGeom>
+          <a:noFill/>
+          <a:ln w="9525">
+            <a:solidFill>
+              <a:srgbClr val="211F30"/>
+            </a:solidFill>
+            <a:prstDash val="solid"/>
+          </a:ln>
+        </p:spPr>
+      </p:sp>
+      <p:sp>
+        <p:nvSpPr>
+          <p:cNvPr id="18" name="Text 15"/>
+          <p:cNvSpPr/>
+          <p:nvPr/>
+        </p:nvSpPr>
+        <p:spPr>
+          <a:xfrm>
+            <a:off x="507950" y="2850356"/>
+            <a:ext cx="4274820" cy="152400"/>
+          </a:xfrm>
+          <a:prstGeom prst="rect">
+            <a:avLst/>
+          </a:prstGeom>
+          <a:noFill/>
+          <a:ln/>
+        </p:spPr>
+        <p:txBody>
+          <a:bodyPr wrap="square" lIns="0" tIns="0" rIns="0" bIns="0" rtlCol="0" anchor="t"/>
+          <a:lstStyle/>
+          <a:p>
+            <a:pPr algn="l" indent="0" marL="0">
+              <a:buNone/>
+            </a:pPr>
+            <a:r>
+              <a:rPr lang="en-US" sz="1050" dirty="0">
+                <a:solidFill>
+                  <a:srgbClr val="D3D4DE"/>
+                </a:solidFill>
+                <a:latin typeface="Arial" pitchFamily="34" charset="0"/>
+                <a:ea typeface="Arial" pitchFamily="34" charset="-122"/>
+                <a:cs typeface="Arial" pitchFamily="34" charset="-120"/>
+              </a:rPr>
+              <a:t>15–20 min wasted searching for parking</a:t>
+            </a:r>
+            <a:endParaRPr lang="en-US" sz="1050" dirty="0"/>
+          </a:p>
+        </p:txBody>
+      </p:sp>
+      <p:sp>
+        <p:nvSpPr>
+          <p:cNvPr id="19" name="Text 16"/>
+          <p:cNvSpPr/>
+          <p:nvPr/>
+        </p:nvSpPr>
+        <p:spPr>
+          <a:xfrm>
+            <a:off x="5008980" y="2850356"/>
+            <a:ext cx="3627069" cy="152400"/>
+          </a:xfrm>
+          <a:prstGeom prst="rect">
+            <a:avLst/>
+          </a:prstGeom>
+          <a:noFill/>
+          <a:ln/>
+        </p:spPr>
+        <p:txBody>
+          <a:bodyPr wrap="square" lIns="0" tIns="0" rIns="0" bIns="0" rtlCol="0" anchor="t"/>
+          <a:lstStyle/>
+          <a:p>
+            <a:pPr algn="r" indent="0" marL="0">
+              <a:buNone/>
+            </a:pPr>
+            <a:r>
+              <a:rPr lang="en-US" sz="1000" dirty="0">
+                <a:solidFill>
+                  <a:srgbClr val="8B8FA6"/>
+                </a:solidFill>
+                <a:latin typeface="Arial" pitchFamily="34" charset="0"/>
+                <a:ea typeface="Arial" pitchFamily="34" charset="-122"/>
+                <a:cs typeface="Arial" pitchFamily="34" charset="-120"/>
+              </a:rPr>
+              <a:t>INRIX parking study / industry research</a:t>
+            </a:r>
+            <a:endParaRPr lang="en-US" sz="1000" dirty="0"/>
+          </a:p>
+        </p:txBody>
+      </p:sp>
+      <p:sp>
+        <p:nvSpPr>
+          <p:cNvPr id="20" name="Shape 17"/>
+          <p:cNvSpPr/>
+          <p:nvPr/>
+        </p:nvSpPr>
+        <p:spPr>
+          <a:xfrm>
+            <a:off x="507950" y="3435995"/>
+            <a:ext cx="8128099" cy="0"/>
+          </a:xfrm>
+          <a:prstGeom prst="line">
+            <a:avLst/>
+          </a:prstGeom>
+          <a:noFill/>
+          <a:ln w="9525">
+            <a:solidFill>
+              <a:srgbClr val="211F30"/>
+            </a:solidFill>
+            <a:prstDash val="solid"/>
+          </a:ln>
+        </p:spPr>
+      </p:sp>
+      <p:sp>
+        <p:nvSpPr>
+          <p:cNvPr id="21" name="Text 18"/>
+          <p:cNvSpPr/>
+          <p:nvPr/>
+        </p:nvSpPr>
+        <p:spPr>
+          <a:xfrm>
+            <a:off x="507950" y="3189982"/>
+            <a:ext cx="4274820" cy="152400"/>
+          </a:xfrm>
+          <a:prstGeom prst="rect">
+            <a:avLst/>
+          </a:prstGeom>
+          <a:noFill/>
+          <a:ln/>
+        </p:spPr>
+        <p:txBody>
+          <a:bodyPr wrap="square" lIns="0" tIns="0" rIns="0" bIns="0" rtlCol="0" anchor="t"/>
+          <a:lstStyle/>
+          <a:p>
+            <a:pPr algn="l" indent="0" marL="0">
+              <a:buNone/>
+            </a:pPr>
+            <a:r>
+              <a:rPr lang="en-US" sz="1050" dirty="0">
+                <a:solidFill>
+                  <a:srgbClr val="D3D4DE"/>
+                </a:solidFill>
+                <a:latin typeface="Arial" pitchFamily="34" charset="0"/>
+                <a:ea typeface="Arial" pitchFamily="34" charset="-122"/>
+                <a:cs typeface="Arial" pitchFamily="34" charset="-120"/>
+              </a:rPr>
+              <a:t>~30% of urban congestion from parking search</a:t>
+            </a:r>
+            <a:endParaRPr lang="en-US" sz="1050" dirty="0"/>
+          </a:p>
+        </p:txBody>
+      </p:sp>
+      <p:sp>
+        <p:nvSpPr>
+          <p:cNvPr id="22" name="Text 19"/>
+          <p:cNvSpPr/>
+          <p:nvPr/>
+        </p:nvSpPr>
+        <p:spPr>
+          <a:xfrm>
+            <a:off x="5008980" y="3189982"/>
+            <a:ext cx="3627069" cy="152400"/>
+          </a:xfrm>
+          <a:prstGeom prst="rect">
+            <a:avLst/>
+          </a:prstGeom>
+          <a:noFill/>
+          <a:ln/>
+        </p:spPr>
+        <p:txBody>
+          <a:bodyPr wrap="square" lIns="0" tIns="0" rIns="0" bIns="0" rtlCol="0" anchor="t"/>
+          <a:lstStyle/>
+          <a:p>
+            <a:pPr algn="r" indent="0" marL="0">
+              <a:buNone/>
+            </a:pPr>
+            <a:r>
+              <a:rPr lang="en-US" sz="1000" dirty="0">
+                <a:solidFill>
+                  <a:srgbClr val="8B8FA6"/>
+                </a:solidFill>
+                <a:latin typeface="Arial" pitchFamily="34" charset="0"/>
+                <a:ea typeface="Arial" pitchFamily="34" charset="-122"/>
+                <a:cs typeface="Arial" pitchFamily="34" charset="-120"/>
+              </a:rPr>
+              <a:t>INRIX / academic research (e.g. D. Shoup)</a:t>
+            </a:r>
+            <a:endParaRPr lang="en-US" sz="1000" dirty="0"/>
+          </a:p>
+        </p:txBody>
+      </p:sp>
+      <p:sp>
+        <p:nvSpPr>
+          <p:cNvPr id="23" name="Shape 20"/>
+          <p:cNvSpPr/>
+          <p:nvPr/>
+        </p:nvSpPr>
+        <p:spPr>
+          <a:xfrm>
+            <a:off x="507950" y="3775621"/>
+            <a:ext cx="8128099" cy="0"/>
+          </a:xfrm>
+          <a:prstGeom prst="line">
+            <a:avLst/>
+          </a:prstGeom>
+          <a:noFill/>
+          <a:ln w="9525">
+            <a:solidFill>
+              <a:srgbClr val="211F30"/>
+            </a:solidFill>
+            <a:prstDash val="solid"/>
+          </a:ln>
+        </p:spPr>
+      </p:sp>
+      <p:sp>
+        <p:nvSpPr>
+          <p:cNvPr id="24" name="Text 21"/>
+          <p:cNvSpPr/>
+          <p:nvPr/>
+        </p:nvSpPr>
+        <p:spPr>
+          <a:xfrm>
+            <a:off x="507950" y="3529608"/>
+            <a:ext cx="4274820" cy="152400"/>
+          </a:xfrm>
+          <a:prstGeom prst="rect">
+            <a:avLst/>
+          </a:prstGeom>
+          <a:noFill/>
+          <a:ln/>
+        </p:spPr>
+        <p:txBody>
+          <a:bodyPr wrap="square" lIns="0" tIns="0" rIns="0" bIns="0" rtlCol="0" anchor="t"/>
+          <a:lstStyle/>
+          <a:p>
+            <a:pPr algn="l" indent="0" marL="0">
+              <a:buNone/>
+            </a:pPr>
+            <a:r>
+              <a:rPr lang="en-US" sz="1050" dirty="0">
+                <a:solidFill>
+                  <a:srgbClr val="D3D4DE"/>
+                </a:solidFill>
+                <a:latin typeface="Arial" pitchFamily="34" charset="0"/>
+                <a:ea typeface="Arial" pitchFamily="34" charset="-122"/>
+                <a:cs typeface="Arial" pitchFamily="34" charset="-120"/>
+              </a:rPr>
+              <a:t>Market size &amp; revenue mix</a:t>
+            </a:r>
+            <a:endParaRPr lang="en-US" sz="1050" dirty="0"/>
+          </a:p>
+        </p:txBody>
+      </p:sp>
+      <p:sp>
+        <p:nvSpPr>
+          <p:cNvPr id="25" name="Text 22"/>
+          <p:cNvSpPr/>
+          <p:nvPr/>
+        </p:nvSpPr>
+        <p:spPr>
+          <a:xfrm>
+            <a:off x="5008980" y="3529608"/>
+            <a:ext cx="3627069" cy="152400"/>
+          </a:xfrm>
+          <a:prstGeom prst="rect">
+            <a:avLst/>
+          </a:prstGeom>
+          <a:noFill/>
+          <a:ln/>
+        </p:spPr>
+        <p:txBody>
+          <a:bodyPr wrap="square" lIns="0" tIns="0" rIns="0" bIns="0" rtlCol="0" anchor="t"/>
+          <a:lstStyle/>
+          <a:p>
+            <a:pPr algn="r" indent="0" marL="0">
+              <a:buNone/>
+            </a:pPr>
+            <a:r>
+              <a:rPr lang="en-US" sz="1000" dirty="0">
+                <a:solidFill>
+                  <a:srgbClr val="8B8FA6"/>
+                </a:solidFill>
+                <a:latin typeface="Arial" pitchFamily="34" charset="0"/>
+                <a:ea typeface="Arial" pitchFamily="34" charset="-122"/>
+                <a:cs typeface="Arial" pitchFamily="34" charset="-120"/>
+              </a:rPr>
+              <a:t>Illustrative — replace with a market report</a:t>
+            </a:r>
+            <a:endParaRPr lang="en-US" sz="1000" dirty="0"/>
+          </a:p>
+        </p:txBody>
+      </p:sp>
+      <p:sp>
+        <p:nvSpPr>
+          <p:cNvPr id="26" name="Text 23"/>
+          <p:cNvSpPr/>
+          <p:nvPr/>
+        </p:nvSpPr>
+        <p:spPr>
+          <a:xfrm>
+            <a:off x="507950" y="4648200"/>
+            <a:ext cx="8290661" cy="114300"/>
+          </a:xfrm>
+          <a:prstGeom prst="rect">
+            <a:avLst/>
+          </a:prstGeom>
+          <a:noFill/>
+          <a:ln/>
+        </p:spPr>
+        <p:txBody>
+          <a:bodyPr wrap="square" lIns="0" tIns="0" rIns="0" bIns="0" rtlCol="0" anchor="t"/>
+          <a:lstStyle/>
+          <a:p>
+            <a:pPr algn="l" indent="0" marL="0">
+              <a:spcBef>
+                <a:spcPts val="6833"/>
+              </a:spcBef>
+              <a:buNone/>
+            </a:pPr>
+            <a:r>
+              <a:rPr lang="en-US" sz="800" dirty="0">
+                <a:solidFill>
+                  <a:srgbClr val="5B5F73"/>
+                </a:solidFill>
+                <a:latin typeface="Arial" pitchFamily="34" charset="0"/>
+                <a:ea typeface="Arial" pitchFamily="34" charset="-122"/>
+                <a:cs typeface="Arial" pitchFamily="34" charset="-120"/>
+              </a:rPr>
+              <a:t>Figures are reported or illustrative and included for discussion. Confirm exact numbers and add primary citations (with year &amp; link) before any public or investor use.</a:t>
+            </a:r>
+            <a:endParaRPr lang="en-US" sz="800" dirty="0"/>
+          </a:p>
+        </p:txBody>
+      </p:sp>
+    </p:spTree>
+  </p:cSld>
+  <p:clrMapOvr>
+    <a:masterClrMapping/>
+  </p:clrMapOvr>
+</p:sld>
+</file>
+
 <file path=ppt/slides/slide2.xml><?xml version="1.0" encoding="utf-8"?>
 <p:sld xmlns:a="http://schemas.openxmlformats.org/drawingml/2006/main" xmlns:r="http://schemas.openxmlformats.org/officeDocument/2006/relationships" xmlns:p="http://schemas.openxmlformats.org/presentationml/2006/main">
   <p:cSld name="Slide 2">
@@ -8449,7 +9424,7 @@
       </p:sp>
       <p:graphicFrame>
         <p:nvGraphicFramePr>
-          <p:cNvPr id="11" name="Chart 0" descr=""/>
+          <p:cNvPr id="12" name="Chart 0" descr=""/>
           <p:cNvGraphicFramePr/>
           <p:nvPr/>
         </p:nvGraphicFramePr>
@@ -8808,7 +9783,7 @@
       </p:sp>
       <p:graphicFrame>
         <p:nvGraphicFramePr>
-          <p:cNvPr id="8" name="Chart 0" descr=""/>
+          <p:cNvPr id="9" name="Chart 0" descr=""/>
           <p:cNvGraphicFramePr/>
           <p:nvPr/>
         </p:nvGraphicFramePr>

</xml_diff>

<commit_message>
Pitch deck: add "How we compare" competitive table
New slide (12) with a capability comparison — ParkEase vs typical maps/search
apps vs existing parking apps — using ✓/✗/~ marks, ParkEase column all-green.
Rows: real-time availability, guaranteed reservation, book & pay ahead, lots +
street + private spaces, owner tools, in-booking monitoring, verified reviews,
AI assistant + EV filters. Framed by category, not specific named products, with
speaker notes. Deck now 14 slides / 14 notes / 3 charts / 1 table.

Co-Authored-By: Claude Opus 4.8 <noreply@anthropic.com>
</commit_message>
<xml_diff>
--- a/ParkEase-Pitch-Deck.pptx
+++ b/ParkEase-Pitch-Deck.pptx
@@ -18,9 +18,10 @@
     <p:sldId id="266" r:id="rId12"/>
     <p:sldId id="267" r:id="rId13"/>
     <p:sldId id="268" r:id="rId14"/>
+    <p:sldId id="269" r:id="rId15"/>
   </p:sldIdLst>
   <p:notesMasterIdLst>
-    <p:notesMasterId r:id="rId15"/>
+    <p:notesMasterId r:id="rId16"/>
   </p:notesMasterIdLst>
   <p:sldSz cx="9144000" cy="5143500"/>
   <p:notesSz cx="5143500" cy="9144000"/>
@@ -1688,7 +1689,7 @@
           <a:p>
             <a:r>
               <a:rPr lang="en-US" dirty="0"/>
-              <a:t>End on the vision and a clear ask. 'Park with certainty, arrive with ease.' State exactly what you're seeking — a pilot, a partnership, mentorship, or funding — and invite questions.</a:t>
+              <a:t>This is the 'why us' proof. Maps/search apps show some parking but can't guarantee or book a spot. Existing parking apps book commercial lots but rarely cover street + private spaces, owner tools, in-booking monitoring or an AI assistant. ParkEase does all of it in one platform — walk down the ParkEase column of green checks.</a:t>
             </a:r>
             <a:endParaRPr lang="en-US" dirty="0"/>
           </a:p>
@@ -1776,7 +1777,7 @@
           <a:p>
             <a:r>
               <a:rPr lang="en-US" dirty="0"/>
-              <a:t>Backup/appendix slide. Use it to answer 'where did these numbers come from?'. Replace each placeholder with the exact primary citation (with year and link) before you present.</a:t>
+              <a:t>End on the vision and a clear ask. 'Park with certainty, arrive with ease.' State exactly what you're seeking — a pilot, a partnership, mentorship, or funding — and invite questions.</a:t>
             </a:r>
             <a:endParaRPr lang="en-US" dirty="0"/>
           </a:p>
@@ -1800,6 +1801,94 @@
             <a:fld id="{F7021451-1387-4CA6-816F-3879F97B5CBC}" type="slidenum">
               <a:rPr lang="en-US"/>
               <a:t>13</a:t>
+            </a:fld>
+            <a:endParaRPr lang="en-US"/>
+          </a:p>
+        </p:txBody>
+      </p:sp>
+    </p:spTree>
+    <p:extLst>
+      <p:ext uri="{BB962C8B-B14F-4D97-AF65-F5344CB8AC3E}">
+        <p14:creationId xmlns:p14="http://schemas.microsoft.com/office/powerpoint/2010/main" val="1024086991"/>
+      </p:ext>
+    </p:extLst>
+  </p:cSld>
+  <p:clrMapOvr>
+    <a:masterClrMapping/>
+  </p:clrMapOvr>
+</p:notes>
+</file>
+
+<file path=ppt/notesSlides/notesSlide14.xml><?xml version="1.0" encoding="utf-8"?>
+<p:notes xmlns:a="http://schemas.openxmlformats.org/drawingml/2006/main" xmlns:r="http://schemas.openxmlformats.org/officeDocument/2006/relationships" xmlns:p="http://schemas.openxmlformats.org/presentationml/2006/main">
+  <p:cSld>
+    <p:spTree>
+      <p:nvGrpSpPr>
+        <p:cNvPr id="1" name=""/>
+        <p:cNvGrpSpPr/>
+        <p:nvPr/>
+      </p:nvGrpSpPr>
+      <p:grpSpPr>
+        <a:xfrm>
+          <a:off x="0" y="0"/>
+          <a:ext cx="0" cy="0"/>
+          <a:chOff x="0" y="0"/>
+          <a:chExt cx="0" cy="0"/>
+        </a:xfrm>
+      </p:grpSpPr>
+      <p:sp>
+        <p:nvSpPr>
+          <p:cNvPr id="2" name="Slide Image Placeholder 1"/>
+          <p:cNvSpPr>
+            <a:spLocks noGrp="1" noRot="1" noChangeAspect="1"/>
+          </p:cNvSpPr>
+          <p:nvPr>
+            <p:ph type="sldImg"/>
+          </p:nvPr>
+        </p:nvSpPr>
+        <p:spPr/>
+      </p:sp>
+      <p:sp>
+        <p:nvSpPr>
+          <p:cNvPr id="3" name="Notes Placeholder 2"/>
+          <p:cNvSpPr>
+            <a:spLocks noGrp="1"/>
+          </p:cNvSpPr>
+          <p:nvPr>
+            <p:ph type="body" idx="1"/>
+          </p:nvPr>
+        </p:nvSpPr>
+        <p:spPr/>
+        <p:txBody>
+          <a:bodyPr/>
+          <a:lstStyle/>
+          <a:p>
+            <a:r>
+              <a:rPr lang="en-US" dirty="0"/>
+              <a:t>Backup/appendix slide. Use it to answer 'where did these numbers come from?'. Replace each placeholder with the exact primary citation (with year and link) before you present.</a:t>
+            </a:r>
+            <a:endParaRPr lang="en-US" dirty="0"/>
+          </a:p>
+        </p:txBody>
+      </p:sp>
+      <p:sp>
+        <p:nvSpPr>
+          <p:cNvPr id="4" name="Slide Number Placeholder 3"/>
+          <p:cNvSpPr>
+            <a:spLocks noGrp="1"/>
+          </p:cNvSpPr>
+          <p:nvPr>
+            <p:ph type="sldNum" sz="quarter" idx="10"/>
+          </p:nvPr>
+        </p:nvSpPr>
+        <p:spPr/>
+        <p:txBody>
+          <a:bodyPr/>
+          <a:lstStyle/>
+          <a:p>
+            <a:fld id="{F7021451-1387-4CA6-816F-3879F97B5CBC}" type="slidenum">
+              <a:rPr lang="en-US"/>
+              <a:t>14</a:t>
             </a:fld>
             <a:endParaRPr lang="en-US"/>
           </a:p>
@@ -3863,7 +3952,7 @@
         </p:nvSpPr>
         <p:spPr>
           <a:xfrm>
-            <a:off x="507950" y="905024"/>
+            <a:off x="507950" y="381000"/>
             <a:ext cx="8290661" cy="152400"/>
           </a:xfrm>
           <a:prstGeom prst="rect">
@@ -3888,7 +3977,7 @@
                 <a:ea typeface="Arial" pitchFamily="34" charset="-122"/>
                 <a:cs typeface="Arial" pitchFamily="34" charset="-120"/>
               </a:rPr>
-              <a:t>THE VISION</a:t>
+              <a:t>HOW WE COMPARE</a:t>
             </a:r>
             <a:endParaRPr lang="en-US" sz="1100" dirty="0"/>
           </a:p>
@@ -3902,8 +3991,8 @@
         </p:nvSpPr>
         <p:spPr>
           <a:xfrm>
-            <a:off x="507950" y="1209824"/>
-            <a:ext cx="8290661" cy="1168003"/>
+            <a:off x="507950" y="634901"/>
+            <a:ext cx="8290661" cy="400050"/>
           </a:xfrm>
           <a:prstGeom prst="rect">
             <a:avLst/>
@@ -3916,16 +4005,13 @@
           <a:lstStyle/>
           <a:p>
             <a:pPr algn="l" indent="0" marL="0">
-              <a:lnSpc>
-                <a:spcPts val="4600"/>
-              </a:lnSpc>
               <a:spcBef>
-                <a:spcPts val="1200"/>
+                <a:spcPts val="800"/>
               </a:spcBef>
               <a:buNone/>
             </a:pPr>
             <a:r>
-              <a:rPr lang="en-US" sz="4000" dirty="0">
+              <a:rPr lang="en-US" sz="2700" b="1" dirty="0">
                 <a:solidFill>
                   <a:srgbClr val="FFFFFF"/>
                 </a:solidFill>
@@ -3933,30 +4019,9 @@
                 <a:ea typeface="Arial" pitchFamily="34" charset="-122"/>
                 <a:cs typeface="Arial" pitchFamily="34" charset="-120"/>
               </a:rPr>
-              <a:t>Park with certainty.
-</a:t>
-            </a:r>
-            <a:pPr algn="l" indent="0" marL="0">
-              <a:lnSpc>
-                <a:spcPts val="4600"/>
-              </a:lnSpc>
-              <a:spcBef>
-                <a:spcPts val="1200"/>
-              </a:spcBef>
-              <a:buNone/>
-            </a:pPr>
-            <a:r>
-              <a:rPr lang="en-US" sz="4000" b="1" dirty="0">
-                <a:solidFill>
-                  <a:srgbClr val="C084FC"/>
-                </a:solidFill>
-                <a:latin typeface="Arial" pitchFamily="34" charset="0"/>
-                <a:ea typeface="Arial" pitchFamily="34" charset="-122"/>
-                <a:cs typeface="Arial" pitchFamily="34" charset="-120"/>
-              </a:rPr>
-              <a:t>Arrive with ease.</a:t>
-            </a:r>
-            <a:endParaRPr lang="en-US" sz="4000" dirty="0"/>
+              <a:t>Better than what’s out there today.</a:t>
+            </a:r>
+            <a:endParaRPr lang="en-US" sz="2700" dirty="0"/>
           </a:p>
         </p:txBody>
       </p:sp>
@@ -3976,8 +4041,8 @@
         </p:blipFill>
         <p:spPr>
           <a:xfrm>
-            <a:off x="507950" y="2580977"/>
-            <a:ext cx="1905000" cy="76200"/>
+            <a:off x="507950" y="1161901"/>
+            <a:ext cx="1143000" cy="63401"/>
           </a:xfrm>
           <a:prstGeom prst="rect">
             <a:avLst/>
@@ -3992,53 +4057,8 @@
         </p:nvSpPr>
         <p:spPr>
           <a:xfrm>
-            <a:off x="507950" y="2885777"/>
-            <a:ext cx="7254139" cy="533400"/>
-          </a:xfrm>
-          <a:prstGeom prst="rect">
-            <a:avLst/>
-          </a:prstGeom>
-          <a:noFill/>
-          <a:ln/>
-        </p:spPr>
-        <p:txBody>
-          <a:bodyPr wrap="square" lIns="0" tIns="0" rIns="0" bIns="0" rtlCol="0" anchor="t"/>
-          <a:lstStyle/>
-          <a:p>
-            <a:pPr algn="l" indent="0" marL="0">
-              <a:lnSpc>
-                <a:spcPts val="2100"/>
-              </a:lnSpc>
-              <a:spcBef>
-                <a:spcPts val="1800"/>
-              </a:spcBef>
-              <a:buNone/>
-            </a:pPr>
-            <a:r>
-              <a:rPr lang="en-US" sz="1400" dirty="0">
-                <a:solidFill>
-                  <a:srgbClr val="C6C8D4"/>
-                </a:solidFill>
-                <a:latin typeface="Arial" pitchFamily="34" charset="0"/>
-                <a:ea typeface="Arial" pitchFamily="34" charset="-122"/>
-                <a:cs typeface="Arial" pitchFamily="34" charset="-120"/>
-              </a:rPr>
-              <a:t>ParkEase turns wasted minutes and avoidable fines into a single tap — making India’s cities move a little more smoothly.</a:t>
-            </a:r>
-            <a:endParaRPr lang="en-US" sz="1400" dirty="0"/>
-          </a:p>
-        </p:txBody>
-      </p:sp>
-      <p:sp>
-        <p:nvSpPr>
-          <p:cNvPr id="6" name="Text 3"/>
-          <p:cNvSpPr/>
-          <p:nvPr/>
-        </p:nvSpPr>
-        <p:spPr>
-          <a:xfrm>
-            <a:off x="507950" y="3723977"/>
-            <a:ext cx="8290661" cy="171450"/>
+            <a:off x="507950" y="4648200"/>
+            <a:ext cx="8290661" cy="114300"/>
           </a:xfrm>
           <a:prstGeom prst="rect">
             <a:avLst/>
@@ -4052,53 +4072,11 @@
           <a:p>
             <a:pPr algn="l" indent="0" marL="0">
               <a:spcBef>
-                <a:spcPts val="2400"/>
+                <a:spcPts val="953"/>
               </a:spcBef>
               <a:buNone/>
             </a:pPr>
             <a:r>
-              <a:rPr lang="en-US" sz="1200" dirty="0">
-                <a:solidFill>
-                  <a:srgbClr val="8B8FA6"/>
-                </a:solidFill>
-                <a:latin typeface="Arial" pitchFamily="34" charset="0"/>
-                <a:ea typeface="Arial" pitchFamily="34" charset="-122"/>
-                <a:cs typeface="Arial" pitchFamily="34" charset="-120"/>
-              </a:rPr>
-              <a:t>Thank you.   Let’s build the future of parking.</a:t>
-            </a:r>
-            <a:endParaRPr lang="en-US" sz="1200" dirty="0"/>
-          </a:p>
-        </p:txBody>
-      </p:sp>
-      <p:sp>
-        <p:nvSpPr>
-          <p:cNvPr id="7" name="Text 4"/>
-          <p:cNvSpPr/>
-          <p:nvPr/>
-        </p:nvSpPr>
-        <p:spPr>
-          <a:xfrm>
-            <a:off x="507950" y="4124027"/>
-            <a:ext cx="8290661" cy="114300"/>
-          </a:xfrm>
-          <a:prstGeom prst="rect">
-            <a:avLst/>
-          </a:prstGeom>
-          <a:noFill/>
-          <a:ln/>
-        </p:spPr>
-        <p:txBody>
-          <a:bodyPr wrap="square" lIns="0" tIns="0" rIns="0" bIns="0" rtlCol="0" anchor="t"/>
-          <a:lstStyle/>
-          <a:p>
-            <a:pPr algn="l" indent="0" marL="0">
-              <a:spcBef>
-                <a:spcPts val="1800"/>
-              </a:spcBef>
-              <a:buNone/>
-            </a:pPr>
-            <a:r>
               <a:rPr lang="en-US" sz="800" dirty="0">
                 <a:solidFill>
                   <a:srgbClr val="5B5F73"/>
@@ -4107,12 +4085,2510 @@
                 <a:ea typeface="Arial" pitchFamily="34" charset="-122"/>
                 <a:cs typeface="Arial" pitchFamily="34" charset="-120"/>
               </a:rPr>
-              <a:t>All statistics are reported/illustrative figures included for discussion; verify and cite primary sources before any public or investor use.</a:t>
+              <a:t>Compared by capability category (typical maps/search apps and existing parking apps) — not a claim about any specific named product.</a:t>
             </a:r>
             <a:endParaRPr lang="en-US" sz="800" dirty="0"/>
           </a:p>
         </p:txBody>
       </p:sp>
+      <p:graphicFrame>
+        <p:nvGraphicFramePr>
+          <p:cNvPr id="13" name="Table 0"/>
+          <p:cNvGraphicFramePr>
+            <a:graphicFrameLocks noGrp="1"/>
+          </p:cNvGraphicFramePr>
+          <p:nvPr>
+            <p:extLst>
+              <p:ext uri="{D42A27DB-BD31-4B8C-83A1-F6EECF244321}">
+                <p14:modId xmlns:p14="http://schemas.microsoft.com/office/powerpoint/2010/main" val="1579011935"/>
+              </p:ext>
+            </p:extLst>
+          </p:nvPr>
+        </p:nvGraphicFramePr>
+        <p:xfrm>
+          <a:off x="507950" y="1377702"/>
+          <a:ext cx="8127950" cy="3149501"/>
+        </p:xfrm>
+        <a:graphic>
+          <a:graphicData uri="http://schemas.openxmlformats.org/drawingml/2006/table">
+            <a:tbl>
+              <a:tblPr/>
+              <a:tblGrid>
+                <a:gridCol w="3007342"/>
+                <a:gridCol w="1828789"/>
+                <a:gridCol w="1828789"/>
+                <a:gridCol w="1463031"/>
+              </a:tblGrid>
+              <a:tr h="384048">
+                <a:tc>
+                  <a:txBody>
+                    <a:bodyPr/>
+                    <a:lstStyle/>
+                    <a:p>
+                      <a:pPr algn="l" indent="0" marL="0">
+                        <a:buNone/>
+                      </a:pPr>
+                      <a:r>
+                        <a:rPr lang="en-US" sz="1050" b="1" dirty="0">
+                          <a:solidFill>
+                            <a:srgbClr val="FFFFFF"/>
+                          </a:solidFill>
+                          <a:latin typeface="Arial" pitchFamily="34" charset="0"/>
+                          <a:ea typeface="Arial" pitchFamily="34" charset="-122"/>
+                          <a:cs typeface="Arial" pitchFamily="34" charset="-120"/>
+                        </a:rPr>
+                        <a:t>Capability</a:t>
+                      </a:r>
+                      <a:endParaRPr lang="en-US" sz="1050" dirty="0">
+                        <a:latin typeface="Arial" charset="0"/>
+                        <a:ea typeface="Arial" charset="0"/>
+                        <a:cs typeface="Arial" charset="0"/>
+                      </a:endParaRPr>
+                    </a:p>
+                  </a:txBody>
+                  <a:tcPr marL="91440" marR="91440" marT="45720" marB="45720" anchor="ctr">
+                    <a:lnL w="6350" cap="flat" cmpd="sng" algn="ctr">
+                      <a:solidFill>
+                        <a:srgbClr val="2A2740"/>
+                      </a:solidFill>
+                      <a:prstDash val="solid"/>
+                      <a:round/>
+                      <a:headEnd type="none" w="med" len="med"/>
+                      <a:tailEnd type="none" w="med" len="med"/>
+                    </a:lnL>
+                    <a:lnR w="6350" cap="flat" cmpd="sng" algn="ctr">
+                      <a:solidFill>
+                        <a:srgbClr val="2A2740"/>
+                      </a:solidFill>
+                      <a:prstDash val="solid"/>
+                      <a:round/>
+                      <a:headEnd type="none" w="med" len="med"/>
+                      <a:tailEnd type="none" w="med" len="med"/>
+                    </a:lnR>
+                    <a:lnT w="6350" cap="flat" cmpd="sng" algn="ctr">
+                      <a:solidFill>
+                        <a:srgbClr val="2A2740"/>
+                      </a:solidFill>
+                      <a:prstDash val="solid"/>
+                      <a:round/>
+                      <a:headEnd type="none" w="med" len="med"/>
+                      <a:tailEnd type="none" w="med" len="med"/>
+                    </a:lnT>
+                    <a:lnB w="6350" cap="flat" cmpd="sng" algn="ctr">
+                      <a:solidFill>
+                        <a:srgbClr val="2A2740"/>
+                      </a:solidFill>
+                      <a:prstDash val="solid"/>
+                      <a:round/>
+                      <a:headEnd type="none" w="med" len="med"/>
+                      <a:tailEnd type="none" w="med" len="med"/>
+                    </a:lnB>
+                    <a:solidFill>
+                      <a:srgbClr val="241F33"/>
+                    </a:solidFill>
+                  </a:tcPr>
+                </a:tc>
+                <a:tc>
+                  <a:txBody>
+                    <a:bodyPr/>
+                    <a:lstStyle/>
+                    <a:p>
+                      <a:pPr algn="ctr" indent="0" marL="0">
+                        <a:buNone/>
+                      </a:pPr>
+                      <a:r>
+                        <a:rPr lang="en-US" sz="1050" b="1" dirty="0">
+                          <a:solidFill>
+                            <a:srgbClr val="FFFFFF"/>
+                          </a:solidFill>
+                          <a:latin typeface="Arial" pitchFamily="34" charset="0"/>
+                          <a:ea typeface="Arial" pitchFamily="34" charset="-122"/>
+                          <a:cs typeface="Arial" pitchFamily="34" charset="-120"/>
+                        </a:rPr>
+                        <a:t>Maps / search apps</a:t>
+                      </a:r>
+                      <a:endParaRPr lang="en-US" sz="1050" dirty="0">
+                        <a:latin typeface="Arial" charset="0"/>
+                        <a:ea typeface="Arial" charset="0"/>
+                        <a:cs typeface="Arial" charset="0"/>
+                      </a:endParaRPr>
+                    </a:p>
+                  </a:txBody>
+                  <a:tcPr marL="91440" marR="91440" marT="45720" marB="45720" anchor="ctr">
+                    <a:lnL w="6350" cap="flat" cmpd="sng" algn="ctr">
+                      <a:solidFill>
+                        <a:srgbClr val="2A2740"/>
+                      </a:solidFill>
+                      <a:prstDash val="solid"/>
+                      <a:round/>
+                      <a:headEnd type="none" w="med" len="med"/>
+                      <a:tailEnd type="none" w="med" len="med"/>
+                    </a:lnL>
+                    <a:lnR w="6350" cap="flat" cmpd="sng" algn="ctr">
+                      <a:solidFill>
+                        <a:srgbClr val="2A2740"/>
+                      </a:solidFill>
+                      <a:prstDash val="solid"/>
+                      <a:round/>
+                      <a:headEnd type="none" w="med" len="med"/>
+                      <a:tailEnd type="none" w="med" len="med"/>
+                    </a:lnR>
+                    <a:lnT w="6350" cap="flat" cmpd="sng" algn="ctr">
+                      <a:solidFill>
+                        <a:srgbClr val="2A2740"/>
+                      </a:solidFill>
+                      <a:prstDash val="solid"/>
+                      <a:round/>
+                      <a:headEnd type="none" w="med" len="med"/>
+                      <a:tailEnd type="none" w="med" len="med"/>
+                    </a:lnT>
+                    <a:lnB w="6350" cap="flat" cmpd="sng" algn="ctr">
+                      <a:solidFill>
+                        <a:srgbClr val="2A2740"/>
+                      </a:solidFill>
+                      <a:prstDash val="solid"/>
+                      <a:round/>
+                      <a:headEnd type="none" w="med" len="med"/>
+                      <a:tailEnd type="none" w="med" len="med"/>
+                    </a:lnB>
+                    <a:solidFill>
+                      <a:srgbClr val="241F33"/>
+                    </a:solidFill>
+                  </a:tcPr>
+                </a:tc>
+                <a:tc>
+                  <a:txBody>
+                    <a:bodyPr/>
+                    <a:lstStyle/>
+                    <a:p>
+                      <a:pPr algn="ctr" indent="0" marL="0">
+                        <a:buNone/>
+                      </a:pPr>
+                      <a:r>
+                        <a:rPr lang="en-US" sz="1050" b="1" dirty="0">
+                          <a:solidFill>
+                            <a:srgbClr val="FFFFFF"/>
+                          </a:solidFill>
+                          <a:latin typeface="Arial" pitchFamily="34" charset="0"/>
+                          <a:ea typeface="Arial" pitchFamily="34" charset="-122"/>
+                          <a:cs typeface="Arial" pitchFamily="34" charset="-120"/>
+                        </a:rPr>
+                        <a:t>Existing parking apps</a:t>
+                      </a:r>
+                      <a:endParaRPr lang="en-US" sz="1050" dirty="0">
+                        <a:latin typeface="Arial" charset="0"/>
+                        <a:ea typeface="Arial" charset="0"/>
+                        <a:cs typeface="Arial" charset="0"/>
+                      </a:endParaRPr>
+                    </a:p>
+                  </a:txBody>
+                  <a:tcPr marL="91440" marR="91440" marT="45720" marB="45720" anchor="ctr">
+                    <a:lnL w="6350" cap="flat" cmpd="sng" algn="ctr">
+                      <a:solidFill>
+                        <a:srgbClr val="2A2740"/>
+                      </a:solidFill>
+                      <a:prstDash val="solid"/>
+                      <a:round/>
+                      <a:headEnd type="none" w="med" len="med"/>
+                      <a:tailEnd type="none" w="med" len="med"/>
+                    </a:lnL>
+                    <a:lnR w="6350" cap="flat" cmpd="sng" algn="ctr">
+                      <a:solidFill>
+                        <a:srgbClr val="2A2740"/>
+                      </a:solidFill>
+                      <a:prstDash val="solid"/>
+                      <a:round/>
+                      <a:headEnd type="none" w="med" len="med"/>
+                      <a:tailEnd type="none" w="med" len="med"/>
+                    </a:lnR>
+                    <a:lnT w="6350" cap="flat" cmpd="sng" algn="ctr">
+                      <a:solidFill>
+                        <a:srgbClr val="2A2740"/>
+                      </a:solidFill>
+                      <a:prstDash val="solid"/>
+                      <a:round/>
+                      <a:headEnd type="none" w="med" len="med"/>
+                      <a:tailEnd type="none" w="med" len="med"/>
+                    </a:lnT>
+                    <a:lnB w="6350" cap="flat" cmpd="sng" algn="ctr">
+                      <a:solidFill>
+                        <a:srgbClr val="2A2740"/>
+                      </a:solidFill>
+                      <a:prstDash val="solid"/>
+                      <a:round/>
+                      <a:headEnd type="none" w="med" len="med"/>
+                      <a:tailEnd type="none" w="med" len="med"/>
+                    </a:lnB>
+                    <a:solidFill>
+                      <a:srgbClr val="241F33"/>
+                    </a:solidFill>
+                  </a:tcPr>
+                </a:tc>
+                <a:tc>
+                  <a:txBody>
+                    <a:bodyPr/>
+                    <a:lstStyle/>
+                    <a:p>
+                      <a:pPr algn="ctr" indent="0" marL="0">
+                        <a:buNone/>
+                      </a:pPr>
+                      <a:r>
+                        <a:rPr lang="en-US" sz="1050" b="1" dirty="0">
+                          <a:solidFill>
+                            <a:srgbClr val="FFFFFF"/>
+                          </a:solidFill>
+                          <a:latin typeface="Arial" pitchFamily="34" charset="0"/>
+                          <a:ea typeface="Arial" pitchFamily="34" charset="-122"/>
+                          <a:cs typeface="Arial" pitchFamily="34" charset="-120"/>
+                        </a:rPr>
+                        <a:t>ParkEase</a:t>
+                      </a:r>
+                      <a:endParaRPr lang="en-US" sz="1050" dirty="0">
+                        <a:latin typeface="Arial" charset="0"/>
+                        <a:ea typeface="Arial" charset="0"/>
+                        <a:cs typeface="Arial" charset="0"/>
+                      </a:endParaRPr>
+                    </a:p>
+                  </a:txBody>
+                  <a:tcPr marL="91440" marR="91440" marT="45720" marB="45720" anchor="ctr">
+                    <a:lnL w="6350" cap="flat" cmpd="sng" algn="ctr">
+                      <a:solidFill>
+                        <a:srgbClr val="2A2740"/>
+                      </a:solidFill>
+                      <a:prstDash val="solid"/>
+                      <a:round/>
+                      <a:headEnd type="none" w="med" len="med"/>
+                      <a:tailEnd type="none" w="med" len="med"/>
+                    </a:lnL>
+                    <a:lnR w="6350" cap="flat" cmpd="sng" algn="ctr">
+                      <a:solidFill>
+                        <a:srgbClr val="2A2740"/>
+                      </a:solidFill>
+                      <a:prstDash val="solid"/>
+                      <a:round/>
+                      <a:headEnd type="none" w="med" len="med"/>
+                      <a:tailEnd type="none" w="med" len="med"/>
+                    </a:lnR>
+                    <a:lnT w="6350" cap="flat" cmpd="sng" algn="ctr">
+                      <a:solidFill>
+                        <a:srgbClr val="2A2740"/>
+                      </a:solidFill>
+                      <a:prstDash val="solid"/>
+                      <a:round/>
+                      <a:headEnd type="none" w="med" len="med"/>
+                      <a:tailEnd type="none" w="med" len="med"/>
+                    </a:lnT>
+                    <a:lnB w="6350" cap="flat" cmpd="sng" algn="ctr">
+                      <a:solidFill>
+                        <a:srgbClr val="2A2740"/>
+                      </a:solidFill>
+                      <a:prstDash val="solid"/>
+                      <a:round/>
+                      <a:headEnd type="none" w="med" len="med"/>
+                      <a:tailEnd type="none" w="med" len="med"/>
+                    </a:lnB>
+                    <a:solidFill>
+                      <a:srgbClr val="A855F7"/>
+                    </a:solidFill>
+                  </a:tcPr>
+                </a:tc>
+              </a:tr>
+              <a:tr h="324612">
+                <a:tc>
+                  <a:txBody>
+                    <a:bodyPr/>
+                    <a:lstStyle/>
+                    <a:p>
+                      <a:pPr algn="l" indent="0" marL="0">
+                        <a:buNone/>
+                      </a:pPr>
+                      <a:r>
+                        <a:rPr lang="en-US" sz="1050" dirty="0">
+                          <a:solidFill>
+                            <a:srgbClr val="E8E8F0"/>
+                          </a:solidFill>
+                          <a:latin typeface="Arial" pitchFamily="34" charset="0"/>
+                          <a:ea typeface="Arial" pitchFamily="34" charset="-122"/>
+                          <a:cs typeface="Arial" pitchFamily="34" charset="-120"/>
+                        </a:rPr>
+                        <a:t>Live, real-time availability</a:t>
+                      </a:r>
+                      <a:endParaRPr lang="en-US" sz="1050" dirty="0">
+                        <a:latin typeface="Arial" charset="0"/>
+                        <a:ea typeface="Arial" charset="0"/>
+                        <a:cs typeface="Arial" charset="0"/>
+                      </a:endParaRPr>
+                    </a:p>
+                  </a:txBody>
+                  <a:tcPr marL="91440" marR="91440" marT="45720" marB="45720" anchor="ctr">
+                    <a:lnL w="6350" cap="flat" cmpd="sng" algn="ctr">
+                      <a:solidFill>
+                        <a:srgbClr val="2A2740"/>
+                      </a:solidFill>
+                      <a:prstDash val="solid"/>
+                      <a:round/>
+                      <a:headEnd type="none" w="med" len="med"/>
+                      <a:tailEnd type="none" w="med" len="med"/>
+                    </a:lnL>
+                    <a:lnR w="6350" cap="flat" cmpd="sng" algn="ctr">
+                      <a:solidFill>
+                        <a:srgbClr val="2A2740"/>
+                      </a:solidFill>
+                      <a:prstDash val="solid"/>
+                      <a:round/>
+                      <a:headEnd type="none" w="med" len="med"/>
+                      <a:tailEnd type="none" w="med" len="med"/>
+                    </a:lnR>
+                    <a:lnT w="6350" cap="flat" cmpd="sng" algn="ctr">
+                      <a:solidFill>
+                        <a:srgbClr val="2A2740"/>
+                      </a:solidFill>
+                      <a:prstDash val="solid"/>
+                      <a:round/>
+                      <a:headEnd type="none" w="med" len="med"/>
+                      <a:tailEnd type="none" w="med" len="med"/>
+                    </a:lnT>
+                    <a:lnB w="6350" cap="flat" cmpd="sng" algn="ctr">
+                      <a:solidFill>
+                        <a:srgbClr val="2A2740"/>
+                      </a:solidFill>
+                      <a:prstDash val="solid"/>
+                      <a:round/>
+                      <a:headEnd type="none" w="med" len="med"/>
+                      <a:tailEnd type="none" w="med" len="med"/>
+                    </a:lnB>
+                    <a:solidFill>
+                      <a:srgbClr val="15131F"/>
+                    </a:solidFill>
+                  </a:tcPr>
+                </a:tc>
+                <a:tc>
+                  <a:txBody>
+                    <a:bodyPr/>
+                    <a:lstStyle/>
+                    <a:p>
+                      <a:pPr algn="ctr" indent="0" marL="0">
+                        <a:buNone/>
+                      </a:pPr>
+                      <a:r>
+                        <a:rPr lang="en-US" sz="1050" b="1" dirty="0">
+                          <a:solidFill>
+                            <a:srgbClr val="FBBF24"/>
+                          </a:solidFill>
+                          <a:latin typeface="Arial" pitchFamily="34" charset="0"/>
+                          <a:ea typeface="Arial" pitchFamily="34" charset="-122"/>
+                          <a:cs typeface="Arial" pitchFamily="34" charset="-120"/>
+                        </a:rPr>
+                        <a:t>~</a:t>
+                      </a:r>
+                      <a:endParaRPr lang="en-US" sz="1050" dirty="0">
+                        <a:latin typeface="Arial" charset="0"/>
+                        <a:ea typeface="Arial" charset="0"/>
+                        <a:cs typeface="Arial" charset="0"/>
+                      </a:endParaRPr>
+                    </a:p>
+                  </a:txBody>
+                  <a:tcPr marL="91440" marR="91440" marT="45720" marB="45720" anchor="ctr">
+                    <a:lnL w="6350" cap="flat" cmpd="sng" algn="ctr">
+                      <a:solidFill>
+                        <a:srgbClr val="2A2740"/>
+                      </a:solidFill>
+                      <a:prstDash val="solid"/>
+                      <a:round/>
+                      <a:headEnd type="none" w="med" len="med"/>
+                      <a:tailEnd type="none" w="med" len="med"/>
+                    </a:lnL>
+                    <a:lnR w="6350" cap="flat" cmpd="sng" algn="ctr">
+                      <a:solidFill>
+                        <a:srgbClr val="2A2740"/>
+                      </a:solidFill>
+                      <a:prstDash val="solid"/>
+                      <a:round/>
+                      <a:headEnd type="none" w="med" len="med"/>
+                      <a:tailEnd type="none" w="med" len="med"/>
+                    </a:lnR>
+                    <a:lnT w="6350" cap="flat" cmpd="sng" algn="ctr">
+                      <a:solidFill>
+                        <a:srgbClr val="2A2740"/>
+                      </a:solidFill>
+                      <a:prstDash val="solid"/>
+                      <a:round/>
+                      <a:headEnd type="none" w="med" len="med"/>
+                      <a:tailEnd type="none" w="med" len="med"/>
+                    </a:lnT>
+                    <a:lnB w="6350" cap="flat" cmpd="sng" algn="ctr">
+                      <a:solidFill>
+                        <a:srgbClr val="2A2740"/>
+                      </a:solidFill>
+                      <a:prstDash val="solid"/>
+                      <a:round/>
+                      <a:headEnd type="none" w="med" len="med"/>
+                      <a:tailEnd type="none" w="med" len="med"/>
+                    </a:lnB>
+                    <a:solidFill>
+                      <a:srgbClr val="15131F"/>
+                    </a:solidFill>
+                  </a:tcPr>
+                </a:tc>
+                <a:tc>
+                  <a:txBody>
+                    <a:bodyPr/>
+                    <a:lstStyle/>
+                    <a:p>
+                      <a:pPr algn="ctr" indent="0" marL="0">
+                        <a:buNone/>
+                      </a:pPr>
+                      <a:r>
+                        <a:rPr lang="en-US" sz="1050" b="1" dirty="0">
+                          <a:solidFill>
+                            <a:srgbClr val="34D399"/>
+                          </a:solidFill>
+                          <a:latin typeface="Arial" pitchFamily="34" charset="0"/>
+                          <a:ea typeface="Arial" pitchFamily="34" charset="-122"/>
+                          <a:cs typeface="Arial" pitchFamily="34" charset="-120"/>
+                        </a:rPr>
+                        <a:t>✓</a:t>
+                      </a:r>
+                      <a:endParaRPr lang="en-US" sz="1050" dirty="0">
+                        <a:latin typeface="Arial" charset="0"/>
+                        <a:ea typeface="Arial" charset="0"/>
+                        <a:cs typeface="Arial" charset="0"/>
+                      </a:endParaRPr>
+                    </a:p>
+                  </a:txBody>
+                  <a:tcPr marL="91440" marR="91440" marT="45720" marB="45720" anchor="ctr">
+                    <a:lnL w="6350" cap="flat" cmpd="sng" algn="ctr">
+                      <a:solidFill>
+                        <a:srgbClr val="2A2740"/>
+                      </a:solidFill>
+                      <a:prstDash val="solid"/>
+                      <a:round/>
+                      <a:headEnd type="none" w="med" len="med"/>
+                      <a:tailEnd type="none" w="med" len="med"/>
+                    </a:lnL>
+                    <a:lnR w="6350" cap="flat" cmpd="sng" algn="ctr">
+                      <a:solidFill>
+                        <a:srgbClr val="2A2740"/>
+                      </a:solidFill>
+                      <a:prstDash val="solid"/>
+                      <a:round/>
+                      <a:headEnd type="none" w="med" len="med"/>
+                      <a:tailEnd type="none" w="med" len="med"/>
+                    </a:lnR>
+                    <a:lnT w="6350" cap="flat" cmpd="sng" algn="ctr">
+                      <a:solidFill>
+                        <a:srgbClr val="2A2740"/>
+                      </a:solidFill>
+                      <a:prstDash val="solid"/>
+                      <a:round/>
+                      <a:headEnd type="none" w="med" len="med"/>
+                      <a:tailEnd type="none" w="med" len="med"/>
+                    </a:lnT>
+                    <a:lnB w="6350" cap="flat" cmpd="sng" algn="ctr">
+                      <a:solidFill>
+                        <a:srgbClr val="2A2740"/>
+                      </a:solidFill>
+                      <a:prstDash val="solid"/>
+                      <a:round/>
+                      <a:headEnd type="none" w="med" len="med"/>
+                      <a:tailEnd type="none" w="med" len="med"/>
+                    </a:lnB>
+                    <a:solidFill>
+                      <a:srgbClr val="15131F"/>
+                    </a:solidFill>
+                  </a:tcPr>
+                </a:tc>
+                <a:tc>
+                  <a:txBody>
+                    <a:bodyPr/>
+                    <a:lstStyle/>
+                    <a:p>
+                      <a:pPr algn="ctr" indent="0" marL="0">
+                        <a:buNone/>
+                      </a:pPr>
+                      <a:r>
+                        <a:rPr lang="en-US" sz="1050" b="1" dirty="0">
+                          <a:solidFill>
+                            <a:srgbClr val="34D399"/>
+                          </a:solidFill>
+                          <a:latin typeface="Arial" pitchFamily="34" charset="0"/>
+                          <a:ea typeface="Arial" pitchFamily="34" charset="-122"/>
+                          <a:cs typeface="Arial" pitchFamily="34" charset="-120"/>
+                        </a:rPr>
+                        <a:t>✓</a:t>
+                      </a:r>
+                      <a:endParaRPr lang="en-US" sz="1050" dirty="0">
+                        <a:latin typeface="Arial" charset="0"/>
+                        <a:ea typeface="Arial" charset="0"/>
+                        <a:cs typeface="Arial" charset="0"/>
+                      </a:endParaRPr>
+                    </a:p>
+                  </a:txBody>
+                  <a:tcPr marL="91440" marR="91440" marT="45720" marB="45720" anchor="ctr">
+                    <a:lnL w="6350" cap="flat" cmpd="sng" algn="ctr">
+                      <a:solidFill>
+                        <a:srgbClr val="2A2740"/>
+                      </a:solidFill>
+                      <a:prstDash val="solid"/>
+                      <a:round/>
+                      <a:headEnd type="none" w="med" len="med"/>
+                      <a:tailEnd type="none" w="med" len="med"/>
+                    </a:lnL>
+                    <a:lnR w="6350" cap="flat" cmpd="sng" algn="ctr">
+                      <a:solidFill>
+                        <a:srgbClr val="2A2740"/>
+                      </a:solidFill>
+                      <a:prstDash val="solid"/>
+                      <a:round/>
+                      <a:headEnd type="none" w="med" len="med"/>
+                      <a:tailEnd type="none" w="med" len="med"/>
+                    </a:lnR>
+                    <a:lnT w="6350" cap="flat" cmpd="sng" algn="ctr">
+                      <a:solidFill>
+                        <a:srgbClr val="2A2740"/>
+                      </a:solidFill>
+                      <a:prstDash val="solid"/>
+                      <a:round/>
+                      <a:headEnd type="none" w="med" len="med"/>
+                      <a:tailEnd type="none" w="med" len="med"/>
+                    </a:lnT>
+                    <a:lnB w="6350" cap="flat" cmpd="sng" algn="ctr">
+                      <a:solidFill>
+                        <a:srgbClr val="2A2740"/>
+                      </a:solidFill>
+                      <a:prstDash val="solid"/>
+                      <a:round/>
+                      <a:headEnd type="none" w="med" len="med"/>
+                      <a:tailEnd type="none" w="med" len="med"/>
+                    </a:lnB>
+                    <a:solidFill>
+                      <a:srgbClr val="20143A"/>
+                    </a:solidFill>
+                  </a:tcPr>
+                </a:tc>
+              </a:tr>
+              <a:tr h="324612">
+                <a:tc>
+                  <a:txBody>
+                    <a:bodyPr/>
+                    <a:lstStyle/>
+                    <a:p>
+                      <a:pPr algn="l" indent="0" marL="0">
+                        <a:buNone/>
+                      </a:pPr>
+                      <a:r>
+                        <a:rPr lang="en-US" sz="1050" dirty="0">
+                          <a:solidFill>
+                            <a:srgbClr val="E8E8F0"/>
+                          </a:solidFill>
+                          <a:latin typeface="Arial" pitchFamily="34" charset="0"/>
+                          <a:ea typeface="Arial" pitchFamily="34" charset="-122"/>
+                          <a:cs typeface="Arial" pitchFamily="34" charset="-120"/>
+                        </a:rPr>
+                        <a:t>Guaranteed reservation (spot held)</a:t>
+                      </a:r>
+                      <a:endParaRPr lang="en-US" sz="1050" dirty="0">
+                        <a:latin typeface="Arial" charset="0"/>
+                        <a:ea typeface="Arial" charset="0"/>
+                        <a:cs typeface="Arial" charset="0"/>
+                      </a:endParaRPr>
+                    </a:p>
+                  </a:txBody>
+                  <a:tcPr marL="91440" marR="91440" marT="45720" marB="45720" anchor="ctr">
+                    <a:lnL w="6350" cap="flat" cmpd="sng" algn="ctr">
+                      <a:solidFill>
+                        <a:srgbClr val="2A2740"/>
+                      </a:solidFill>
+                      <a:prstDash val="solid"/>
+                      <a:round/>
+                      <a:headEnd type="none" w="med" len="med"/>
+                      <a:tailEnd type="none" w="med" len="med"/>
+                    </a:lnL>
+                    <a:lnR w="6350" cap="flat" cmpd="sng" algn="ctr">
+                      <a:solidFill>
+                        <a:srgbClr val="2A2740"/>
+                      </a:solidFill>
+                      <a:prstDash val="solid"/>
+                      <a:round/>
+                      <a:headEnd type="none" w="med" len="med"/>
+                      <a:tailEnd type="none" w="med" len="med"/>
+                    </a:lnR>
+                    <a:lnT w="6350" cap="flat" cmpd="sng" algn="ctr">
+                      <a:solidFill>
+                        <a:srgbClr val="2A2740"/>
+                      </a:solidFill>
+                      <a:prstDash val="solid"/>
+                      <a:round/>
+                      <a:headEnd type="none" w="med" len="med"/>
+                      <a:tailEnd type="none" w="med" len="med"/>
+                    </a:lnT>
+                    <a:lnB w="6350" cap="flat" cmpd="sng" algn="ctr">
+                      <a:solidFill>
+                        <a:srgbClr val="2A2740"/>
+                      </a:solidFill>
+                      <a:prstDash val="solid"/>
+                      <a:round/>
+                      <a:headEnd type="none" w="med" len="med"/>
+                      <a:tailEnd type="none" w="med" len="med"/>
+                    </a:lnB>
+                    <a:solidFill>
+                      <a:srgbClr val="15131F"/>
+                    </a:solidFill>
+                  </a:tcPr>
+                </a:tc>
+                <a:tc>
+                  <a:txBody>
+                    <a:bodyPr/>
+                    <a:lstStyle/>
+                    <a:p>
+                      <a:pPr algn="ctr" indent="0" marL="0">
+                        <a:buNone/>
+                      </a:pPr>
+                      <a:r>
+                        <a:rPr lang="en-US" sz="1050" b="1" dirty="0">
+                          <a:solidFill>
+                            <a:srgbClr val="FB7185"/>
+                          </a:solidFill>
+                          <a:latin typeface="Arial" pitchFamily="34" charset="0"/>
+                          <a:ea typeface="Arial" pitchFamily="34" charset="-122"/>
+                          <a:cs typeface="Arial" pitchFamily="34" charset="-120"/>
+                        </a:rPr>
+                        <a:t>✗</a:t>
+                      </a:r>
+                      <a:endParaRPr lang="en-US" sz="1050" dirty="0">
+                        <a:latin typeface="Arial" charset="0"/>
+                        <a:ea typeface="Arial" charset="0"/>
+                        <a:cs typeface="Arial" charset="0"/>
+                      </a:endParaRPr>
+                    </a:p>
+                  </a:txBody>
+                  <a:tcPr marL="91440" marR="91440" marT="45720" marB="45720" anchor="ctr">
+                    <a:lnL w="6350" cap="flat" cmpd="sng" algn="ctr">
+                      <a:solidFill>
+                        <a:srgbClr val="2A2740"/>
+                      </a:solidFill>
+                      <a:prstDash val="solid"/>
+                      <a:round/>
+                      <a:headEnd type="none" w="med" len="med"/>
+                      <a:tailEnd type="none" w="med" len="med"/>
+                    </a:lnL>
+                    <a:lnR w="6350" cap="flat" cmpd="sng" algn="ctr">
+                      <a:solidFill>
+                        <a:srgbClr val="2A2740"/>
+                      </a:solidFill>
+                      <a:prstDash val="solid"/>
+                      <a:round/>
+                      <a:headEnd type="none" w="med" len="med"/>
+                      <a:tailEnd type="none" w="med" len="med"/>
+                    </a:lnR>
+                    <a:lnT w="6350" cap="flat" cmpd="sng" algn="ctr">
+                      <a:solidFill>
+                        <a:srgbClr val="2A2740"/>
+                      </a:solidFill>
+                      <a:prstDash val="solid"/>
+                      <a:round/>
+                      <a:headEnd type="none" w="med" len="med"/>
+                      <a:tailEnd type="none" w="med" len="med"/>
+                    </a:lnT>
+                    <a:lnB w="6350" cap="flat" cmpd="sng" algn="ctr">
+                      <a:solidFill>
+                        <a:srgbClr val="2A2740"/>
+                      </a:solidFill>
+                      <a:prstDash val="solid"/>
+                      <a:round/>
+                      <a:headEnd type="none" w="med" len="med"/>
+                      <a:tailEnd type="none" w="med" len="med"/>
+                    </a:lnB>
+                    <a:solidFill>
+                      <a:srgbClr val="15131F"/>
+                    </a:solidFill>
+                  </a:tcPr>
+                </a:tc>
+                <a:tc>
+                  <a:txBody>
+                    <a:bodyPr/>
+                    <a:lstStyle/>
+                    <a:p>
+                      <a:pPr algn="ctr" indent="0" marL="0">
+                        <a:buNone/>
+                      </a:pPr>
+                      <a:r>
+                        <a:rPr lang="en-US" sz="1050" b="1" dirty="0">
+                          <a:solidFill>
+                            <a:srgbClr val="34D399"/>
+                          </a:solidFill>
+                          <a:latin typeface="Arial" pitchFamily="34" charset="0"/>
+                          <a:ea typeface="Arial" pitchFamily="34" charset="-122"/>
+                          <a:cs typeface="Arial" pitchFamily="34" charset="-120"/>
+                        </a:rPr>
+                        <a:t>✓</a:t>
+                      </a:r>
+                      <a:endParaRPr lang="en-US" sz="1050" dirty="0">
+                        <a:latin typeface="Arial" charset="0"/>
+                        <a:ea typeface="Arial" charset="0"/>
+                        <a:cs typeface="Arial" charset="0"/>
+                      </a:endParaRPr>
+                    </a:p>
+                  </a:txBody>
+                  <a:tcPr marL="91440" marR="91440" marT="45720" marB="45720" anchor="ctr">
+                    <a:lnL w="6350" cap="flat" cmpd="sng" algn="ctr">
+                      <a:solidFill>
+                        <a:srgbClr val="2A2740"/>
+                      </a:solidFill>
+                      <a:prstDash val="solid"/>
+                      <a:round/>
+                      <a:headEnd type="none" w="med" len="med"/>
+                      <a:tailEnd type="none" w="med" len="med"/>
+                    </a:lnL>
+                    <a:lnR w="6350" cap="flat" cmpd="sng" algn="ctr">
+                      <a:solidFill>
+                        <a:srgbClr val="2A2740"/>
+                      </a:solidFill>
+                      <a:prstDash val="solid"/>
+                      <a:round/>
+                      <a:headEnd type="none" w="med" len="med"/>
+                      <a:tailEnd type="none" w="med" len="med"/>
+                    </a:lnR>
+                    <a:lnT w="6350" cap="flat" cmpd="sng" algn="ctr">
+                      <a:solidFill>
+                        <a:srgbClr val="2A2740"/>
+                      </a:solidFill>
+                      <a:prstDash val="solid"/>
+                      <a:round/>
+                      <a:headEnd type="none" w="med" len="med"/>
+                      <a:tailEnd type="none" w="med" len="med"/>
+                    </a:lnT>
+                    <a:lnB w="6350" cap="flat" cmpd="sng" algn="ctr">
+                      <a:solidFill>
+                        <a:srgbClr val="2A2740"/>
+                      </a:solidFill>
+                      <a:prstDash val="solid"/>
+                      <a:round/>
+                      <a:headEnd type="none" w="med" len="med"/>
+                      <a:tailEnd type="none" w="med" len="med"/>
+                    </a:lnB>
+                    <a:solidFill>
+                      <a:srgbClr val="15131F"/>
+                    </a:solidFill>
+                  </a:tcPr>
+                </a:tc>
+                <a:tc>
+                  <a:txBody>
+                    <a:bodyPr/>
+                    <a:lstStyle/>
+                    <a:p>
+                      <a:pPr algn="ctr" indent="0" marL="0">
+                        <a:buNone/>
+                      </a:pPr>
+                      <a:r>
+                        <a:rPr lang="en-US" sz="1050" b="1" dirty="0">
+                          <a:solidFill>
+                            <a:srgbClr val="34D399"/>
+                          </a:solidFill>
+                          <a:latin typeface="Arial" pitchFamily="34" charset="0"/>
+                          <a:ea typeface="Arial" pitchFamily="34" charset="-122"/>
+                          <a:cs typeface="Arial" pitchFamily="34" charset="-120"/>
+                        </a:rPr>
+                        <a:t>✓</a:t>
+                      </a:r>
+                      <a:endParaRPr lang="en-US" sz="1050" dirty="0">
+                        <a:latin typeface="Arial" charset="0"/>
+                        <a:ea typeface="Arial" charset="0"/>
+                        <a:cs typeface="Arial" charset="0"/>
+                      </a:endParaRPr>
+                    </a:p>
+                  </a:txBody>
+                  <a:tcPr marL="91440" marR="91440" marT="45720" marB="45720" anchor="ctr">
+                    <a:lnL w="6350" cap="flat" cmpd="sng" algn="ctr">
+                      <a:solidFill>
+                        <a:srgbClr val="2A2740"/>
+                      </a:solidFill>
+                      <a:prstDash val="solid"/>
+                      <a:round/>
+                      <a:headEnd type="none" w="med" len="med"/>
+                      <a:tailEnd type="none" w="med" len="med"/>
+                    </a:lnL>
+                    <a:lnR w="6350" cap="flat" cmpd="sng" algn="ctr">
+                      <a:solidFill>
+                        <a:srgbClr val="2A2740"/>
+                      </a:solidFill>
+                      <a:prstDash val="solid"/>
+                      <a:round/>
+                      <a:headEnd type="none" w="med" len="med"/>
+                      <a:tailEnd type="none" w="med" len="med"/>
+                    </a:lnR>
+                    <a:lnT w="6350" cap="flat" cmpd="sng" algn="ctr">
+                      <a:solidFill>
+                        <a:srgbClr val="2A2740"/>
+                      </a:solidFill>
+                      <a:prstDash val="solid"/>
+                      <a:round/>
+                      <a:headEnd type="none" w="med" len="med"/>
+                      <a:tailEnd type="none" w="med" len="med"/>
+                    </a:lnT>
+                    <a:lnB w="6350" cap="flat" cmpd="sng" algn="ctr">
+                      <a:solidFill>
+                        <a:srgbClr val="2A2740"/>
+                      </a:solidFill>
+                      <a:prstDash val="solid"/>
+                      <a:round/>
+                      <a:headEnd type="none" w="med" len="med"/>
+                      <a:tailEnd type="none" w="med" len="med"/>
+                    </a:lnB>
+                    <a:solidFill>
+                      <a:srgbClr val="20143A"/>
+                    </a:solidFill>
+                  </a:tcPr>
+                </a:tc>
+              </a:tr>
+              <a:tr h="324612">
+                <a:tc>
+                  <a:txBody>
+                    <a:bodyPr/>
+                    <a:lstStyle/>
+                    <a:p>
+                      <a:pPr algn="l" indent="0" marL="0">
+                        <a:buNone/>
+                      </a:pPr>
+                      <a:r>
+                        <a:rPr lang="en-US" sz="1050" dirty="0">
+                          <a:solidFill>
+                            <a:srgbClr val="E8E8F0"/>
+                          </a:solidFill>
+                          <a:latin typeface="Arial" pitchFamily="34" charset="0"/>
+                          <a:ea typeface="Arial" pitchFamily="34" charset="-122"/>
+                          <a:cs typeface="Arial" pitchFamily="34" charset="-120"/>
+                        </a:rPr>
+                        <a:t>Book &amp; pay in advance (UPI / cards)</a:t>
+                      </a:r>
+                      <a:endParaRPr lang="en-US" sz="1050" dirty="0">
+                        <a:latin typeface="Arial" charset="0"/>
+                        <a:ea typeface="Arial" charset="0"/>
+                        <a:cs typeface="Arial" charset="0"/>
+                      </a:endParaRPr>
+                    </a:p>
+                  </a:txBody>
+                  <a:tcPr marL="91440" marR="91440" marT="45720" marB="45720" anchor="ctr">
+                    <a:lnL w="6350" cap="flat" cmpd="sng" algn="ctr">
+                      <a:solidFill>
+                        <a:srgbClr val="2A2740"/>
+                      </a:solidFill>
+                      <a:prstDash val="solid"/>
+                      <a:round/>
+                      <a:headEnd type="none" w="med" len="med"/>
+                      <a:tailEnd type="none" w="med" len="med"/>
+                    </a:lnL>
+                    <a:lnR w="6350" cap="flat" cmpd="sng" algn="ctr">
+                      <a:solidFill>
+                        <a:srgbClr val="2A2740"/>
+                      </a:solidFill>
+                      <a:prstDash val="solid"/>
+                      <a:round/>
+                      <a:headEnd type="none" w="med" len="med"/>
+                      <a:tailEnd type="none" w="med" len="med"/>
+                    </a:lnR>
+                    <a:lnT w="6350" cap="flat" cmpd="sng" algn="ctr">
+                      <a:solidFill>
+                        <a:srgbClr val="2A2740"/>
+                      </a:solidFill>
+                      <a:prstDash val="solid"/>
+                      <a:round/>
+                      <a:headEnd type="none" w="med" len="med"/>
+                      <a:tailEnd type="none" w="med" len="med"/>
+                    </a:lnT>
+                    <a:lnB w="6350" cap="flat" cmpd="sng" algn="ctr">
+                      <a:solidFill>
+                        <a:srgbClr val="2A2740"/>
+                      </a:solidFill>
+                      <a:prstDash val="solid"/>
+                      <a:round/>
+                      <a:headEnd type="none" w="med" len="med"/>
+                      <a:tailEnd type="none" w="med" len="med"/>
+                    </a:lnB>
+                    <a:solidFill>
+                      <a:srgbClr val="15131F"/>
+                    </a:solidFill>
+                  </a:tcPr>
+                </a:tc>
+                <a:tc>
+                  <a:txBody>
+                    <a:bodyPr/>
+                    <a:lstStyle/>
+                    <a:p>
+                      <a:pPr algn="ctr" indent="0" marL="0">
+                        <a:buNone/>
+                      </a:pPr>
+                      <a:r>
+                        <a:rPr lang="en-US" sz="1050" b="1" dirty="0">
+                          <a:solidFill>
+                            <a:srgbClr val="FB7185"/>
+                          </a:solidFill>
+                          <a:latin typeface="Arial" pitchFamily="34" charset="0"/>
+                          <a:ea typeface="Arial" pitchFamily="34" charset="-122"/>
+                          <a:cs typeface="Arial" pitchFamily="34" charset="-120"/>
+                        </a:rPr>
+                        <a:t>✗</a:t>
+                      </a:r>
+                      <a:endParaRPr lang="en-US" sz="1050" dirty="0">
+                        <a:latin typeface="Arial" charset="0"/>
+                        <a:ea typeface="Arial" charset="0"/>
+                        <a:cs typeface="Arial" charset="0"/>
+                      </a:endParaRPr>
+                    </a:p>
+                  </a:txBody>
+                  <a:tcPr marL="91440" marR="91440" marT="45720" marB="45720" anchor="ctr">
+                    <a:lnL w="6350" cap="flat" cmpd="sng" algn="ctr">
+                      <a:solidFill>
+                        <a:srgbClr val="2A2740"/>
+                      </a:solidFill>
+                      <a:prstDash val="solid"/>
+                      <a:round/>
+                      <a:headEnd type="none" w="med" len="med"/>
+                      <a:tailEnd type="none" w="med" len="med"/>
+                    </a:lnL>
+                    <a:lnR w="6350" cap="flat" cmpd="sng" algn="ctr">
+                      <a:solidFill>
+                        <a:srgbClr val="2A2740"/>
+                      </a:solidFill>
+                      <a:prstDash val="solid"/>
+                      <a:round/>
+                      <a:headEnd type="none" w="med" len="med"/>
+                      <a:tailEnd type="none" w="med" len="med"/>
+                    </a:lnR>
+                    <a:lnT w="6350" cap="flat" cmpd="sng" algn="ctr">
+                      <a:solidFill>
+                        <a:srgbClr val="2A2740"/>
+                      </a:solidFill>
+                      <a:prstDash val="solid"/>
+                      <a:round/>
+                      <a:headEnd type="none" w="med" len="med"/>
+                      <a:tailEnd type="none" w="med" len="med"/>
+                    </a:lnT>
+                    <a:lnB w="6350" cap="flat" cmpd="sng" algn="ctr">
+                      <a:solidFill>
+                        <a:srgbClr val="2A2740"/>
+                      </a:solidFill>
+                      <a:prstDash val="solid"/>
+                      <a:round/>
+                      <a:headEnd type="none" w="med" len="med"/>
+                      <a:tailEnd type="none" w="med" len="med"/>
+                    </a:lnB>
+                    <a:solidFill>
+                      <a:srgbClr val="15131F"/>
+                    </a:solidFill>
+                  </a:tcPr>
+                </a:tc>
+                <a:tc>
+                  <a:txBody>
+                    <a:bodyPr/>
+                    <a:lstStyle/>
+                    <a:p>
+                      <a:pPr algn="ctr" indent="0" marL="0">
+                        <a:buNone/>
+                      </a:pPr>
+                      <a:r>
+                        <a:rPr lang="en-US" sz="1050" b="1" dirty="0">
+                          <a:solidFill>
+                            <a:srgbClr val="34D399"/>
+                          </a:solidFill>
+                          <a:latin typeface="Arial" pitchFamily="34" charset="0"/>
+                          <a:ea typeface="Arial" pitchFamily="34" charset="-122"/>
+                          <a:cs typeface="Arial" pitchFamily="34" charset="-120"/>
+                        </a:rPr>
+                        <a:t>✓</a:t>
+                      </a:r>
+                      <a:endParaRPr lang="en-US" sz="1050" dirty="0">
+                        <a:latin typeface="Arial" charset="0"/>
+                        <a:ea typeface="Arial" charset="0"/>
+                        <a:cs typeface="Arial" charset="0"/>
+                      </a:endParaRPr>
+                    </a:p>
+                  </a:txBody>
+                  <a:tcPr marL="91440" marR="91440" marT="45720" marB="45720" anchor="ctr">
+                    <a:lnL w="6350" cap="flat" cmpd="sng" algn="ctr">
+                      <a:solidFill>
+                        <a:srgbClr val="2A2740"/>
+                      </a:solidFill>
+                      <a:prstDash val="solid"/>
+                      <a:round/>
+                      <a:headEnd type="none" w="med" len="med"/>
+                      <a:tailEnd type="none" w="med" len="med"/>
+                    </a:lnL>
+                    <a:lnR w="6350" cap="flat" cmpd="sng" algn="ctr">
+                      <a:solidFill>
+                        <a:srgbClr val="2A2740"/>
+                      </a:solidFill>
+                      <a:prstDash val="solid"/>
+                      <a:round/>
+                      <a:headEnd type="none" w="med" len="med"/>
+                      <a:tailEnd type="none" w="med" len="med"/>
+                    </a:lnR>
+                    <a:lnT w="6350" cap="flat" cmpd="sng" algn="ctr">
+                      <a:solidFill>
+                        <a:srgbClr val="2A2740"/>
+                      </a:solidFill>
+                      <a:prstDash val="solid"/>
+                      <a:round/>
+                      <a:headEnd type="none" w="med" len="med"/>
+                      <a:tailEnd type="none" w="med" len="med"/>
+                    </a:lnT>
+                    <a:lnB w="6350" cap="flat" cmpd="sng" algn="ctr">
+                      <a:solidFill>
+                        <a:srgbClr val="2A2740"/>
+                      </a:solidFill>
+                      <a:prstDash val="solid"/>
+                      <a:round/>
+                      <a:headEnd type="none" w="med" len="med"/>
+                      <a:tailEnd type="none" w="med" len="med"/>
+                    </a:lnB>
+                    <a:solidFill>
+                      <a:srgbClr val="15131F"/>
+                    </a:solidFill>
+                  </a:tcPr>
+                </a:tc>
+                <a:tc>
+                  <a:txBody>
+                    <a:bodyPr/>
+                    <a:lstStyle/>
+                    <a:p>
+                      <a:pPr algn="ctr" indent="0" marL="0">
+                        <a:buNone/>
+                      </a:pPr>
+                      <a:r>
+                        <a:rPr lang="en-US" sz="1050" b="1" dirty="0">
+                          <a:solidFill>
+                            <a:srgbClr val="34D399"/>
+                          </a:solidFill>
+                          <a:latin typeface="Arial" pitchFamily="34" charset="0"/>
+                          <a:ea typeface="Arial" pitchFamily="34" charset="-122"/>
+                          <a:cs typeface="Arial" pitchFamily="34" charset="-120"/>
+                        </a:rPr>
+                        <a:t>✓</a:t>
+                      </a:r>
+                      <a:endParaRPr lang="en-US" sz="1050" dirty="0">
+                        <a:latin typeface="Arial" charset="0"/>
+                        <a:ea typeface="Arial" charset="0"/>
+                        <a:cs typeface="Arial" charset="0"/>
+                      </a:endParaRPr>
+                    </a:p>
+                  </a:txBody>
+                  <a:tcPr marL="91440" marR="91440" marT="45720" marB="45720" anchor="ctr">
+                    <a:lnL w="6350" cap="flat" cmpd="sng" algn="ctr">
+                      <a:solidFill>
+                        <a:srgbClr val="2A2740"/>
+                      </a:solidFill>
+                      <a:prstDash val="solid"/>
+                      <a:round/>
+                      <a:headEnd type="none" w="med" len="med"/>
+                      <a:tailEnd type="none" w="med" len="med"/>
+                    </a:lnL>
+                    <a:lnR w="6350" cap="flat" cmpd="sng" algn="ctr">
+                      <a:solidFill>
+                        <a:srgbClr val="2A2740"/>
+                      </a:solidFill>
+                      <a:prstDash val="solid"/>
+                      <a:round/>
+                      <a:headEnd type="none" w="med" len="med"/>
+                      <a:tailEnd type="none" w="med" len="med"/>
+                    </a:lnR>
+                    <a:lnT w="6350" cap="flat" cmpd="sng" algn="ctr">
+                      <a:solidFill>
+                        <a:srgbClr val="2A2740"/>
+                      </a:solidFill>
+                      <a:prstDash val="solid"/>
+                      <a:round/>
+                      <a:headEnd type="none" w="med" len="med"/>
+                      <a:tailEnd type="none" w="med" len="med"/>
+                    </a:lnT>
+                    <a:lnB w="6350" cap="flat" cmpd="sng" algn="ctr">
+                      <a:solidFill>
+                        <a:srgbClr val="2A2740"/>
+                      </a:solidFill>
+                      <a:prstDash val="solid"/>
+                      <a:round/>
+                      <a:headEnd type="none" w="med" len="med"/>
+                      <a:tailEnd type="none" w="med" len="med"/>
+                    </a:lnB>
+                    <a:solidFill>
+                      <a:srgbClr val="20143A"/>
+                    </a:solidFill>
+                  </a:tcPr>
+                </a:tc>
+              </a:tr>
+              <a:tr h="324612">
+                <a:tc>
+                  <a:txBody>
+                    <a:bodyPr/>
+                    <a:lstStyle/>
+                    <a:p>
+                      <a:pPr algn="l" indent="0" marL="0">
+                        <a:buNone/>
+                      </a:pPr>
+                      <a:r>
+                        <a:rPr lang="en-US" sz="1050" dirty="0">
+                          <a:solidFill>
+                            <a:srgbClr val="E8E8F0"/>
+                          </a:solidFill>
+                          <a:latin typeface="Arial" pitchFamily="34" charset="0"/>
+                          <a:ea typeface="Arial" pitchFamily="34" charset="-122"/>
+                          <a:cs typeface="Arial" pitchFamily="34" charset="-120"/>
+                        </a:rPr>
+                        <a:t>Lots + street + private spaces</a:t>
+                      </a:r>
+                      <a:endParaRPr lang="en-US" sz="1050" dirty="0">
+                        <a:latin typeface="Arial" charset="0"/>
+                        <a:ea typeface="Arial" charset="0"/>
+                        <a:cs typeface="Arial" charset="0"/>
+                      </a:endParaRPr>
+                    </a:p>
+                  </a:txBody>
+                  <a:tcPr marL="91440" marR="91440" marT="45720" marB="45720" anchor="ctr">
+                    <a:lnL w="6350" cap="flat" cmpd="sng" algn="ctr">
+                      <a:solidFill>
+                        <a:srgbClr val="2A2740"/>
+                      </a:solidFill>
+                      <a:prstDash val="solid"/>
+                      <a:round/>
+                      <a:headEnd type="none" w="med" len="med"/>
+                      <a:tailEnd type="none" w="med" len="med"/>
+                    </a:lnL>
+                    <a:lnR w="6350" cap="flat" cmpd="sng" algn="ctr">
+                      <a:solidFill>
+                        <a:srgbClr val="2A2740"/>
+                      </a:solidFill>
+                      <a:prstDash val="solid"/>
+                      <a:round/>
+                      <a:headEnd type="none" w="med" len="med"/>
+                      <a:tailEnd type="none" w="med" len="med"/>
+                    </a:lnR>
+                    <a:lnT w="6350" cap="flat" cmpd="sng" algn="ctr">
+                      <a:solidFill>
+                        <a:srgbClr val="2A2740"/>
+                      </a:solidFill>
+                      <a:prstDash val="solid"/>
+                      <a:round/>
+                      <a:headEnd type="none" w="med" len="med"/>
+                      <a:tailEnd type="none" w="med" len="med"/>
+                    </a:lnT>
+                    <a:lnB w="6350" cap="flat" cmpd="sng" algn="ctr">
+                      <a:solidFill>
+                        <a:srgbClr val="2A2740"/>
+                      </a:solidFill>
+                      <a:prstDash val="solid"/>
+                      <a:round/>
+                      <a:headEnd type="none" w="med" len="med"/>
+                      <a:tailEnd type="none" w="med" len="med"/>
+                    </a:lnB>
+                    <a:solidFill>
+                      <a:srgbClr val="15131F"/>
+                    </a:solidFill>
+                  </a:tcPr>
+                </a:tc>
+                <a:tc>
+                  <a:txBody>
+                    <a:bodyPr/>
+                    <a:lstStyle/>
+                    <a:p>
+                      <a:pPr algn="ctr" indent="0" marL="0">
+                        <a:buNone/>
+                      </a:pPr>
+                      <a:r>
+                        <a:rPr lang="en-US" sz="1050" b="1" dirty="0">
+                          <a:solidFill>
+                            <a:srgbClr val="FBBF24"/>
+                          </a:solidFill>
+                          <a:latin typeface="Arial" pitchFamily="34" charset="0"/>
+                          <a:ea typeface="Arial" pitchFamily="34" charset="-122"/>
+                          <a:cs typeface="Arial" pitchFamily="34" charset="-120"/>
+                        </a:rPr>
+                        <a:t>~</a:t>
+                      </a:r>
+                      <a:endParaRPr lang="en-US" sz="1050" dirty="0">
+                        <a:latin typeface="Arial" charset="0"/>
+                        <a:ea typeface="Arial" charset="0"/>
+                        <a:cs typeface="Arial" charset="0"/>
+                      </a:endParaRPr>
+                    </a:p>
+                  </a:txBody>
+                  <a:tcPr marL="91440" marR="91440" marT="45720" marB="45720" anchor="ctr">
+                    <a:lnL w="6350" cap="flat" cmpd="sng" algn="ctr">
+                      <a:solidFill>
+                        <a:srgbClr val="2A2740"/>
+                      </a:solidFill>
+                      <a:prstDash val="solid"/>
+                      <a:round/>
+                      <a:headEnd type="none" w="med" len="med"/>
+                      <a:tailEnd type="none" w="med" len="med"/>
+                    </a:lnL>
+                    <a:lnR w="6350" cap="flat" cmpd="sng" algn="ctr">
+                      <a:solidFill>
+                        <a:srgbClr val="2A2740"/>
+                      </a:solidFill>
+                      <a:prstDash val="solid"/>
+                      <a:round/>
+                      <a:headEnd type="none" w="med" len="med"/>
+                      <a:tailEnd type="none" w="med" len="med"/>
+                    </a:lnR>
+                    <a:lnT w="6350" cap="flat" cmpd="sng" algn="ctr">
+                      <a:solidFill>
+                        <a:srgbClr val="2A2740"/>
+                      </a:solidFill>
+                      <a:prstDash val="solid"/>
+                      <a:round/>
+                      <a:headEnd type="none" w="med" len="med"/>
+                      <a:tailEnd type="none" w="med" len="med"/>
+                    </a:lnT>
+                    <a:lnB w="6350" cap="flat" cmpd="sng" algn="ctr">
+                      <a:solidFill>
+                        <a:srgbClr val="2A2740"/>
+                      </a:solidFill>
+                      <a:prstDash val="solid"/>
+                      <a:round/>
+                      <a:headEnd type="none" w="med" len="med"/>
+                      <a:tailEnd type="none" w="med" len="med"/>
+                    </a:lnB>
+                    <a:solidFill>
+                      <a:srgbClr val="15131F"/>
+                    </a:solidFill>
+                  </a:tcPr>
+                </a:tc>
+                <a:tc>
+                  <a:txBody>
+                    <a:bodyPr/>
+                    <a:lstStyle/>
+                    <a:p>
+                      <a:pPr algn="ctr" indent="0" marL="0">
+                        <a:buNone/>
+                      </a:pPr>
+                      <a:r>
+                        <a:rPr lang="en-US" sz="1050" b="1" dirty="0">
+                          <a:solidFill>
+                            <a:srgbClr val="FBBF24"/>
+                          </a:solidFill>
+                          <a:latin typeface="Arial" pitchFamily="34" charset="0"/>
+                          <a:ea typeface="Arial" pitchFamily="34" charset="-122"/>
+                          <a:cs typeface="Arial" pitchFamily="34" charset="-120"/>
+                        </a:rPr>
+                        <a:t>~</a:t>
+                      </a:r>
+                      <a:endParaRPr lang="en-US" sz="1050" dirty="0">
+                        <a:latin typeface="Arial" charset="0"/>
+                        <a:ea typeface="Arial" charset="0"/>
+                        <a:cs typeface="Arial" charset="0"/>
+                      </a:endParaRPr>
+                    </a:p>
+                  </a:txBody>
+                  <a:tcPr marL="91440" marR="91440" marT="45720" marB="45720" anchor="ctr">
+                    <a:lnL w="6350" cap="flat" cmpd="sng" algn="ctr">
+                      <a:solidFill>
+                        <a:srgbClr val="2A2740"/>
+                      </a:solidFill>
+                      <a:prstDash val="solid"/>
+                      <a:round/>
+                      <a:headEnd type="none" w="med" len="med"/>
+                      <a:tailEnd type="none" w="med" len="med"/>
+                    </a:lnL>
+                    <a:lnR w="6350" cap="flat" cmpd="sng" algn="ctr">
+                      <a:solidFill>
+                        <a:srgbClr val="2A2740"/>
+                      </a:solidFill>
+                      <a:prstDash val="solid"/>
+                      <a:round/>
+                      <a:headEnd type="none" w="med" len="med"/>
+                      <a:tailEnd type="none" w="med" len="med"/>
+                    </a:lnR>
+                    <a:lnT w="6350" cap="flat" cmpd="sng" algn="ctr">
+                      <a:solidFill>
+                        <a:srgbClr val="2A2740"/>
+                      </a:solidFill>
+                      <a:prstDash val="solid"/>
+                      <a:round/>
+                      <a:headEnd type="none" w="med" len="med"/>
+                      <a:tailEnd type="none" w="med" len="med"/>
+                    </a:lnT>
+                    <a:lnB w="6350" cap="flat" cmpd="sng" algn="ctr">
+                      <a:solidFill>
+                        <a:srgbClr val="2A2740"/>
+                      </a:solidFill>
+                      <a:prstDash val="solid"/>
+                      <a:round/>
+                      <a:headEnd type="none" w="med" len="med"/>
+                      <a:tailEnd type="none" w="med" len="med"/>
+                    </a:lnB>
+                    <a:solidFill>
+                      <a:srgbClr val="15131F"/>
+                    </a:solidFill>
+                  </a:tcPr>
+                </a:tc>
+                <a:tc>
+                  <a:txBody>
+                    <a:bodyPr/>
+                    <a:lstStyle/>
+                    <a:p>
+                      <a:pPr algn="ctr" indent="0" marL="0">
+                        <a:buNone/>
+                      </a:pPr>
+                      <a:r>
+                        <a:rPr lang="en-US" sz="1050" b="1" dirty="0">
+                          <a:solidFill>
+                            <a:srgbClr val="34D399"/>
+                          </a:solidFill>
+                          <a:latin typeface="Arial" pitchFamily="34" charset="0"/>
+                          <a:ea typeface="Arial" pitchFamily="34" charset="-122"/>
+                          <a:cs typeface="Arial" pitchFamily="34" charset="-120"/>
+                        </a:rPr>
+                        <a:t>✓</a:t>
+                      </a:r>
+                      <a:endParaRPr lang="en-US" sz="1050" dirty="0">
+                        <a:latin typeface="Arial" charset="0"/>
+                        <a:ea typeface="Arial" charset="0"/>
+                        <a:cs typeface="Arial" charset="0"/>
+                      </a:endParaRPr>
+                    </a:p>
+                  </a:txBody>
+                  <a:tcPr marL="91440" marR="91440" marT="45720" marB="45720" anchor="ctr">
+                    <a:lnL w="6350" cap="flat" cmpd="sng" algn="ctr">
+                      <a:solidFill>
+                        <a:srgbClr val="2A2740"/>
+                      </a:solidFill>
+                      <a:prstDash val="solid"/>
+                      <a:round/>
+                      <a:headEnd type="none" w="med" len="med"/>
+                      <a:tailEnd type="none" w="med" len="med"/>
+                    </a:lnL>
+                    <a:lnR w="6350" cap="flat" cmpd="sng" algn="ctr">
+                      <a:solidFill>
+                        <a:srgbClr val="2A2740"/>
+                      </a:solidFill>
+                      <a:prstDash val="solid"/>
+                      <a:round/>
+                      <a:headEnd type="none" w="med" len="med"/>
+                      <a:tailEnd type="none" w="med" len="med"/>
+                    </a:lnR>
+                    <a:lnT w="6350" cap="flat" cmpd="sng" algn="ctr">
+                      <a:solidFill>
+                        <a:srgbClr val="2A2740"/>
+                      </a:solidFill>
+                      <a:prstDash val="solid"/>
+                      <a:round/>
+                      <a:headEnd type="none" w="med" len="med"/>
+                      <a:tailEnd type="none" w="med" len="med"/>
+                    </a:lnT>
+                    <a:lnB w="6350" cap="flat" cmpd="sng" algn="ctr">
+                      <a:solidFill>
+                        <a:srgbClr val="2A2740"/>
+                      </a:solidFill>
+                      <a:prstDash val="solid"/>
+                      <a:round/>
+                      <a:headEnd type="none" w="med" len="med"/>
+                      <a:tailEnd type="none" w="med" len="med"/>
+                    </a:lnB>
+                    <a:solidFill>
+                      <a:srgbClr val="20143A"/>
+                    </a:solidFill>
+                  </a:tcPr>
+                </a:tc>
+              </a:tr>
+              <a:tr h="324612">
+                <a:tc>
+                  <a:txBody>
+                    <a:bodyPr/>
+                    <a:lstStyle/>
+                    <a:p>
+                      <a:pPr algn="l" indent="0" marL="0">
+                        <a:buNone/>
+                      </a:pPr>
+                      <a:r>
+                        <a:rPr lang="en-US" sz="1050" dirty="0">
+                          <a:solidFill>
+                            <a:srgbClr val="E8E8F0"/>
+                          </a:solidFill>
+                          <a:latin typeface="Arial" pitchFamily="34" charset="0"/>
+                          <a:ea typeface="Arial" pitchFamily="34" charset="-122"/>
+                          <a:cs typeface="Arial" pitchFamily="34" charset="-120"/>
+                        </a:rPr>
+                        <a:t>Owner self-listing &amp; revenue tools</a:t>
+                      </a:r>
+                      <a:endParaRPr lang="en-US" sz="1050" dirty="0">
+                        <a:latin typeface="Arial" charset="0"/>
+                        <a:ea typeface="Arial" charset="0"/>
+                        <a:cs typeface="Arial" charset="0"/>
+                      </a:endParaRPr>
+                    </a:p>
+                  </a:txBody>
+                  <a:tcPr marL="91440" marR="91440" marT="45720" marB="45720" anchor="ctr">
+                    <a:lnL w="6350" cap="flat" cmpd="sng" algn="ctr">
+                      <a:solidFill>
+                        <a:srgbClr val="2A2740"/>
+                      </a:solidFill>
+                      <a:prstDash val="solid"/>
+                      <a:round/>
+                      <a:headEnd type="none" w="med" len="med"/>
+                      <a:tailEnd type="none" w="med" len="med"/>
+                    </a:lnL>
+                    <a:lnR w="6350" cap="flat" cmpd="sng" algn="ctr">
+                      <a:solidFill>
+                        <a:srgbClr val="2A2740"/>
+                      </a:solidFill>
+                      <a:prstDash val="solid"/>
+                      <a:round/>
+                      <a:headEnd type="none" w="med" len="med"/>
+                      <a:tailEnd type="none" w="med" len="med"/>
+                    </a:lnR>
+                    <a:lnT w="6350" cap="flat" cmpd="sng" algn="ctr">
+                      <a:solidFill>
+                        <a:srgbClr val="2A2740"/>
+                      </a:solidFill>
+                      <a:prstDash val="solid"/>
+                      <a:round/>
+                      <a:headEnd type="none" w="med" len="med"/>
+                      <a:tailEnd type="none" w="med" len="med"/>
+                    </a:lnT>
+                    <a:lnB w="6350" cap="flat" cmpd="sng" algn="ctr">
+                      <a:solidFill>
+                        <a:srgbClr val="2A2740"/>
+                      </a:solidFill>
+                      <a:prstDash val="solid"/>
+                      <a:round/>
+                      <a:headEnd type="none" w="med" len="med"/>
+                      <a:tailEnd type="none" w="med" len="med"/>
+                    </a:lnB>
+                    <a:solidFill>
+                      <a:srgbClr val="15131F"/>
+                    </a:solidFill>
+                  </a:tcPr>
+                </a:tc>
+                <a:tc>
+                  <a:txBody>
+                    <a:bodyPr/>
+                    <a:lstStyle/>
+                    <a:p>
+                      <a:pPr algn="ctr" indent="0" marL="0">
+                        <a:buNone/>
+                      </a:pPr>
+                      <a:r>
+                        <a:rPr lang="en-US" sz="1050" b="1" dirty="0">
+                          <a:solidFill>
+                            <a:srgbClr val="FB7185"/>
+                          </a:solidFill>
+                          <a:latin typeface="Arial" pitchFamily="34" charset="0"/>
+                          <a:ea typeface="Arial" pitchFamily="34" charset="-122"/>
+                          <a:cs typeface="Arial" pitchFamily="34" charset="-120"/>
+                        </a:rPr>
+                        <a:t>✗</a:t>
+                      </a:r>
+                      <a:endParaRPr lang="en-US" sz="1050" dirty="0">
+                        <a:latin typeface="Arial" charset="0"/>
+                        <a:ea typeface="Arial" charset="0"/>
+                        <a:cs typeface="Arial" charset="0"/>
+                      </a:endParaRPr>
+                    </a:p>
+                  </a:txBody>
+                  <a:tcPr marL="91440" marR="91440" marT="45720" marB="45720" anchor="ctr">
+                    <a:lnL w="6350" cap="flat" cmpd="sng" algn="ctr">
+                      <a:solidFill>
+                        <a:srgbClr val="2A2740"/>
+                      </a:solidFill>
+                      <a:prstDash val="solid"/>
+                      <a:round/>
+                      <a:headEnd type="none" w="med" len="med"/>
+                      <a:tailEnd type="none" w="med" len="med"/>
+                    </a:lnL>
+                    <a:lnR w="6350" cap="flat" cmpd="sng" algn="ctr">
+                      <a:solidFill>
+                        <a:srgbClr val="2A2740"/>
+                      </a:solidFill>
+                      <a:prstDash val="solid"/>
+                      <a:round/>
+                      <a:headEnd type="none" w="med" len="med"/>
+                      <a:tailEnd type="none" w="med" len="med"/>
+                    </a:lnR>
+                    <a:lnT w="6350" cap="flat" cmpd="sng" algn="ctr">
+                      <a:solidFill>
+                        <a:srgbClr val="2A2740"/>
+                      </a:solidFill>
+                      <a:prstDash val="solid"/>
+                      <a:round/>
+                      <a:headEnd type="none" w="med" len="med"/>
+                      <a:tailEnd type="none" w="med" len="med"/>
+                    </a:lnT>
+                    <a:lnB w="6350" cap="flat" cmpd="sng" algn="ctr">
+                      <a:solidFill>
+                        <a:srgbClr val="2A2740"/>
+                      </a:solidFill>
+                      <a:prstDash val="solid"/>
+                      <a:round/>
+                      <a:headEnd type="none" w="med" len="med"/>
+                      <a:tailEnd type="none" w="med" len="med"/>
+                    </a:lnB>
+                    <a:solidFill>
+                      <a:srgbClr val="15131F"/>
+                    </a:solidFill>
+                  </a:tcPr>
+                </a:tc>
+                <a:tc>
+                  <a:txBody>
+                    <a:bodyPr/>
+                    <a:lstStyle/>
+                    <a:p>
+                      <a:pPr algn="ctr" indent="0" marL="0">
+                        <a:buNone/>
+                      </a:pPr>
+                      <a:r>
+                        <a:rPr lang="en-US" sz="1050" b="1" dirty="0">
+                          <a:solidFill>
+                            <a:srgbClr val="FBBF24"/>
+                          </a:solidFill>
+                          <a:latin typeface="Arial" pitchFamily="34" charset="0"/>
+                          <a:ea typeface="Arial" pitchFamily="34" charset="-122"/>
+                          <a:cs typeface="Arial" pitchFamily="34" charset="-120"/>
+                        </a:rPr>
+                        <a:t>~</a:t>
+                      </a:r>
+                      <a:endParaRPr lang="en-US" sz="1050" dirty="0">
+                        <a:latin typeface="Arial" charset="0"/>
+                        <a:ea typeface="Arial" charset="0"/>
+                        <a:cs typeface="Arial" charset="0"/>
+                      </a:endParaRPr>
+                    </a:p>
+                  </a:txBody>
+                  <a:tcPr marL="91440" marR="91440" marT="45720" marB="45720" anchor="ctr">
+                    <a:lnL w="6350" cap="flat" cmpd="sng" algn="ctr">
+                      <a:solidFill>
+                        <a:srgbClr val="2A2740"/>
+                      </a:solidFill>
+                      <a:prstDash val="solid"/>
+                      <a:round/>
+                      <a:headEnd type="none" w="med" len="med"/>
+                      <a:tailEnd type="none" w="med" len="med"/>
+                    </a:lnL>
+                    <a:lnR w="6350" cap="flat" cmpd="sng" algn="ctr">
+                      <a:solidFill>
+                        <a:srgbClr val="2A2740"/>
+                      </a:solidFill>
+                      <a:prstDash val="solid"/>
+                      <a:round/>
+                      <a:headEnd type="none" w="med" len="med"/>
+                      <a:tailEnd type="none" w="med" len="med"/>
+                    </a:lnR>
+                    <a:lnT w="6350" cap="flat" cmpd="sng" algn="ctr">
+                      <a:solidFill>
+                        <a:srgbClr val="2A2740"/>
+                      </a:solidFill>
+                      <a:prstDash val="solid"/>
+                      <a:round/>
+                      <a:headEnd type="none" w="med" len="med"/>
+                      <a:tailEnd type="none" w="med" len="med"/>
+                    </a:lnT>
+                    <a:lnB w="6350" cap="flat" cmpd="sng" algn="ctr">
+                      <a:solidFill>
+                        <a:srgbClr val="2A2740"/>
+                      </a:solidFill>
+                      <a:prstDash val="solid"/>
+                      <a:round/>
+                      <a:headEnd type="none" w="med" len="med"/>
+                      <a:tailEnd type="none" w="med" len="med"/>
+                    </a:lnB>
+                    <a:solidFill>
+                      <a:srgbClr val="15131F"/>
+                    </a:solidFill>
+                  </a:tcPr>
+                </a:tc>
+                <a:tc>
+                  <a:txBody>
+                    <a:bodyPr/>
+                    <a:lstStyle/>
+                    <a:p>
+                      <a:pPr algn="ctr" indent="0" marL="0">
+                        <a:buNone/>
+                      </a:pPr>
+                      <a:r>
+                        <a:rPr lang="en-US" sz="1050" b="1" dirty="0">
+                          <a:solidFill>
+                            <a:srgbClr val="34D399"/>
+                          </a:solidFill>
+                          <a:latin typeface="Arial" pitchFamily="34" charset="0"/>
+                          <a:ea typeface="Arial" pitchFamily="34" charset="-122"/>
+                          <a:cs typeface="Arial" pitchFamily="34" charset="-120"/>
+                        </a:rPr>
+                        <a:t>✓</a:t>
+                      </a:r>
+                      <a:endParaRPr lang="en-US" sz="1050" dirty="0">
+                        <a:latin typeface="Arial" charset="0"/>
+                        <a:ea typeface="Arial" charset="0"/>
+                        <a:cs typeface="Arial" charset="0"/>
+                      </a:endParaRPr>
+                    </a:p>
+                  </a:txBody>
+                  <a:tcPr marL="91440" marR="91440" marT="45720" marB="45720" anchor="ctr">
+                    <a:lnL w="6350" cap="flat" cmpd="sng" algn="ctr">
+                      <a:solidFill>
+                        <a:srgbClr val="2A2740"/>
+                      </a:solidFill>
+                      <a:prstDash val="solid"/>
+                      <a:round/>
+                      <a:headEnd type="none" w="med" len="med"/>
+                      <a:tailEnd type="none" w="med" len="med"/>
+                    </a:lnL>
+                    <a:lnR w="6350" cap="flat" cmpd="sng" algn="ctr">
+                      <a:solidFill>
+                        <a:srgbClr val="2A2740"/>
+                      </a:solidFill>
+                      <a:prstDash val="solid"/>
+                      <a:round/>
+                      <a:headEnd type="none" w="med" len="med"/>
+                      <a:tailEnd type="none" w="med" len="med"/>
+                    </a:lnR>
+                    <a:lnT w="6350" cap="flat" cmpd="sng" algn="ctr">
+                      <a:solidFill>
+                        <a:srgbClr val="2A2740"/>
+                      </a:solidFill>
+                      <a:prstDash val="solid"/>
+                      <a:round/>
+                      <a:headEnd type="none" w="med" len="med"/>
+                      <a:tailEnd type="none" w="med" len="med"/>
+                    </a:lnT>
+                    <a:lnB w="6350" cap="flat" cmpd="sng" algn="ctr">
+                      <a:solidFill>
+                        <a:srgbClr val="2A2740"/>
+                      </a:solidFill>
+                      <a:prstDash val="solid"/>
+                      <a:round/>
+                      <a:headEnd type="none" w="med" len="med"/>
+                      <a:tailEnd type="none" w="med" len="med"/>
+                    </a:lnB>
+                    <a:solidFill>
+                      <a:srgbClr val="20143A"/>
+                    </a:solidFill>
+                  </a:tcPr>
+                </a:tc>
+              </a:tr>
+              <a:tr h="324612">
+                <a:tc>
+                  <a:txBody>
+                    <a:bodyPr/>
+                    <a:lstStyle/>
+                    <a:p>
+                      <a:pPr algn="l" indent="0" marL="0">
+                        <a:buNone/>
+                      </a:pPr>
+                      <a:r>
+                        <a:rPr lang="en-US" sz="1050" dirty="0">
+                          <a:solidFill>
+                            <a:srgbClr val="E8E8F0"/>
+                          </a:solidFill>
+                          <a:latin typeface="Arial" pitchFamily="34" charset="0"/>
+                          <a:ea typeface="Arial" pitchFamily="34" charset="-122"/>
+                          <a:cs typeface="Arial" pitchFamily="34" charset="-120"/>
+                        </a:rPr>
+                        <a:t>In-booking security monitoring</a:t>
+                      </a:r>
+                      <a:endParaRPr lang="en-US" sz="1050" dirty="0">
+                        <a:latin typeface="Arial" charset="0"/>
+                        <a:ea typeface="Arial" charset="0"/>
+                        <a:cs typeface="Arial" charset="0"/>
+                      </a:endParaRPr>
+                    </a:p>
+                  </a:txBody>
+                  <a:tcPr marL="91440" marR="91440" marT="45720" marB="45720" anchor="ctr">
+                    <a:lnL w="6350" cap="flat" cmpd="sng" algn="ctr">
+                      <a:solidFill>
+                        <a:srgbClr val="2A2740"/>
+                      </a:solidFill>
+                      <a:prstDash val="solid"/>
+                      <a:round/>
+                      <a:headEnd type="none" w="med" len="med"/>
+                      <a:tailEnd type="none" w="med" len="med"/>
+                    </a:lnL>
+                    <a:lnR w="6350" cap="flat" cmpd="sng" algn="ctr">
+                      <a:solidFill>
+                        <a:srgbClr val="2A2740"/>
+                      </a:solidFill>
+                      <a:prstDash val="solid"/>
+                      <a:round/>
+                      <a:headEnd type="none" w="med" len="med"/>
+                      <a:tailEnd type="none" w="med" len="med"/>
+                    </a:lnR>
+                    <a:lnT w="6350" cap="flat" cmpd="sng" algn="ctr">
+                      <a:solidFill>
+                        <a:srgbClr val="2A2740"/>
+                      </a:solidFill>
+                      <a:prstDash val="solid"/>
+                      <a:round/>
+                      <a:headEnd type="none" w="med" len="med"/>
+                      <a:tailEnd type="none" w="med" len="med"/>
+                    </a:lnT>
+                    <a:lnB w="6350" cap="flat" cmpd="sng" algn="ctr">
+                      <a:solidFill>
+                        <a:srgbClr val="2A2740"/>
+                      </a:solidFill>
+                      <a:prstDash val="solid"/>
+                      <a:round/>
+                      <a:headEnd type="none" w="med" len="med"/>
+                      <a:tailEnd type="none" w="med" len="med"/>
+                    </a:lnB>
+                    <a:solidFill>
+                      <a:srgbClr val="15131F"/>
+                    </a:solidFill>
+                  </a:tcPr>
+                </a:tc>
+                <a:tc>
+                  <a:txBody>
+                    <a:bodyPr/>
+                    <a:lstStyle/>
+                    <a:p>
+                      <a:pPr algn="ctr" indent="0" marL="0">
+                        <a:buNone/>
+                      </a:pPr>
+                      <a:r>
+                        <a:rPr lang="en-US" sz="1050" b="1" dirty="0">
+                          <a:solidFill>
+                            <a:srgbClr val="FB7185"/>
+                          </a:solidFill>
+                          <a:latin typeface="Arial" pitchFamily="34" charset="0"/>
+                          <a:ea typeface="Arial" pitchFamily="34" charset="-122"/>
+                          <a:cs typeface="Arial" pitchFamily="34" charset="-120"/>
+                        </a:rPr>
+                        <a:t>✗</a:t>
+                      </a:r>
+                      <a:endParaRPr lang="en-US" sz="1050" dirty="0">
+                        <a:latin typeface="Arial" charset="0"/>
+                        <a:ea typeface="Arial" charset="0"/>
+                        <a:cs typeface="Arial" charset="0"/>
+                      </a:endParaRPr>
+                    </a:p>
+                  </a:txBody>
+                  <a:tcPr marL="91440" marR="91440" marT="45720" marB="45720" anchor="ctr">
+                    <a:lnL w="6350" cap="flat" cmpd="sng" algn="ctr">
+                      <a:solidFill>
+                        <a:srgbClr val="2A2740"/>
+                      </a:solidFill>
+                      <a:prstDash val="solid"/>
+                      <a:round/>
+                      <a:headEnd type="none" w="med" len="med"/>
+                      <a:tailEnd type="none" w="med" len="med"/>
+                    </a:lnL>
+                    <a:lnR w="6350" cap="flat" cmpd="sng" algn="ctr">
+                      <a:solidFill>
+                        <a:srgbClr val="2A2740"/>
+                      </a:solidFill>
+                      <a:prstDash val="solid"/>
+                      <a:round/>
+                      <a:headEnd type="none" w="med" len="med"/>
+                      <a:tailEnd type="none" w="med" len="med"/>
+                    </a:lnR>
+                    <a:lnT w="6350" cap="flat" cmpd="sng" algn="ctr">
+                      <a:solidFill>
+                        <a:srgbClr val="2A2740"/>
+                      </a:solidFill>
+                      <a:prstDash val="solid"/>
+                      <a:round/>
+                      <a:headEnd type="none" w="med" len="med"/>
+                      <a:tailEnd type="none" w="med" len="med"/>
+                    </a:lnT>
+                    <a:lnB w="6350" cap="flat" cmpd="sng" algn="ctr">
+                      <a:solidFill>
+                        <a:srgbClr val="2A2740"/>
+                      </a:solidFill>
+                      <a:prstDash val="solid"/>
+                      <a:round/>
+                      <a:headEnd type="none" w="med" len="med"/>
+                      <a:tailEnd type="none" w="med" len="med"/>
+                    </a:lnB>
+                    <a:solidFill>
+                      <a:srgbClr val="15131F"/>
+                    </a:solidFill>
+                  </a:tcPr>
+                </a:tc>
+                <a:tc>
+                  <a:txBody>
+                    <a:bodyPr/>
+                    <a:lstStyle/>
+                    <a:p>
+                      <a:pPr algn="ctr" indent="0" marL="0">
+                        <a:buNone/>
+                      </a:pPr>
+                      <a:r>
+                        <a:rPr lang="en-US" sz="1050" b="1" dirty="0">
+                          <a:solidFill>
+                            <a:srgbClr val="FB7185"/>
+                          </a:solidFill>
+                          <a:latin typeface="Arial" pitchFamily="34" charset="0"/>
+                          <a:ea typeface="Arial" pitchFamily="34" charset="-122"/>
+                          <a:cs typeface="Arial" pitchFamily="34" charset="-120"/>
+                        </a:rPr>
+                        <a:t>✗</a:t>
+                      </a:r>
+                      <a:endParaRPr lang="en-US" sz="1050" dirty="0">
+                        <a:latin typeface="Arial" charset="0"/>
+                        <a:ea typeface="Arial" charset="0"/>
+                        <a:cs typeface="Arial" charset="0"/>
+                      </a:endParaRPr>
+                    </a:p>
+                  </a:txBody>
+                  <a:tcPr marL="91440" marR="91440" marT="45720" marB="45720" anchor="ctr">
+                    <a:lnL w="6350" cap="flat" cmpd="sng" algn="ctr">
+                      <a:solidFill>
+                        <a:srgbClr val="2A2740"/>
+                      </a:solidFill>
+                      <a:prstDash val="solid"/>
+                      <a:round/>
+                      <a:headEnd type="none" w="med" len="med"/>
+                      <a:tailEnd type="none" w="med" len="med"/>
+                    </a:lnL>
+                    <a:lnR w="6350" cap="flat" cmpd="sng" algn="ctr">
+                      <a:solidFill>
+                        <a:srgbClr val="2A2740"/>
+                      </a:solidFill>
+                      <a:prstDash val="solid"/>
+                      <a:round/>
+                      <a:headEnd type="none" w="med" len="med"/>
+                      <a:tailEnd type="none" w="med" len="med"/>
+                    </a:lnR>
+                    <a:lnT w="6350" cap="flat" cmpd="sng" algn="ctr">
+                      <a:solidFill>
+                        <a:srgbClr val="2A2740"/>
+                      </a:solidFill>
+                      <a:prstDash val="solid"/>
+                      <a:round/>
+                      <a:headEnd type="none" w="med" len="med"/>
+                      <a:tailEnd type="none" w="med" len="med"/>
+                    </a:lnT>
+                    <a:lnB w="6350" cap="flat" cmpd="sng" algn="ctr">
+                      <a:solidFill>
+                        <a:srgbClr val="2A2740"/>
+                      </a:solidFill>
+                      <a:prstDash val="solid"/>
+                      <a:round/>
+                      <a:headEnd type="none" w="med" len="med"/>
+                      <a:tailEnd type="none" w="med" len="med"/>
+                    </a:lnB>
+                    <a:solidFill>
+                      <a:srgbClr val="15131F"/>
+                    </a:solidFill>
+                  </a:tcPr>
+                </a:tc>
+                <a:tc>
+                  <a:txBody>
+                    <a:bodyPr/>
+                    <a:lstStyle/>
+                    <a:p>
+                      <a:pPr algn="ctr" indent="0" marL="0">
+                        <a:buNone/>
+                      </a:pPr>
+                      <a:r>
+                        <a:rPr lang="en-US" sz="1050" b="1" dirty="0">
+                          <a:solidFill>
+                            <a:srgbClr val="34D399"/>
+                          </a:solidFill>
+                          <a:latin typeface="Arial" pitchFamily="34" charset="0"/>
+                          <a:ea typeface="Arial" pitchFamily="34" charset="-122"/>
+                          <a:cs typeface="Arial" pitchFamily="34" charset="-120"/>
+                        </a:rPr>
+                        <a:t>✓</a:t>
+                      </a:r>
+                      <a:endParaRPr lang="en-US" sz="1050" dirty="0">
+                        <a:latin typeface="Arial" charset="0"/>
+                        <a:ea typeface="Arial" charset="0"/>
+                        <a:cs typeface="Arial" charset="0"/>
+                      </a:endParaRPr>
+                    </a:p>
+                  </a:txBody>
+                  <a:tcPr marL="91440" marR="91440" marT="45720" marB="45720" anchor="ctr">
+                    <a:lnL w="6350" cap="flat" cmpd="sng" algn="ctr">
+                      <a:solidFill>
+                        <a:srgbClr val="2A2740"/>
+                      </a:solidFill>
+                      <a:prstDash val="solid"/>
+                      <a:round/>
+                      <a:headEnd type="none" w="med" len="med"/>
+                      <a:tailEnd type="none" w="med" len="med"/>
+                    </a:lnL>
+                    <a:lnR w="6350" cap="flat" cmpd="sng" algn="ctr">
+                      <a:solidFill>
+                        <a:srgbClr val="2A2740"/>
+                      </a:solidFill>
+                      <a:prstDash val="solid"/>
+                      <a:round/>
+                      <a:headEnd type="none" w="med" len="med"/>
+                      <a:tailEnd type="none" w="med" len="med"/>
+                    </a:lnR>
+                    <a:lnT w="6350" cap="flat" cmpd="sng" algn="ctr">
+                      <a:solidFill>
+                        <a:srgbClr val="2A2740"/>
+                      </a:solidFill>
+                      <a:prstDash val="solid"/>
+                      <a:round/>
+                      <a:headEnd type="none" w="med" len="med"/>
+                      <a:tailEnd type="none" w="med" len="med"/>
+                    </a:lnT>
+                    <a:lnB w="6350" cap="flat" cmpd="sng" algn="ctr">
+                      <a:solidFill>
+                        <a:srgbClr val="2A2740"/>
+                      </a:solidFill>
+                      <a:prstDash val="solid"/>
+                      <a:round/>
+                      <a:headEnd type="none" w="med" len="med"/>
+                      <a:tailEnd type="none" w="med" len="med"/>
+                    </a:lnB>
+                    <a:solidFill>
+                      <a:srgbClr val="20143A"/>
+                    </a:solidFill>
+                  </a:tcPr>
+                </a:tc>
+              </a:tr>
+              <a:tr h="324612">
+                <a:tc>
+                  <a:txBody>
+                    <a:bodyPr/>
+                    <a:lstStyle/>
+                    <a:p>
+                      <a:pPr algn="l" indent="0" marL="0">
+                        <a:buNone/>
+                      </a:pPr>
+                      <a:r>
+                        <a:rPr lang="en-US" sz="1050" dirty="0">
+                          <a:solidFill>
+                            <a:srgbClr val="E8E8F0"/>
+                          </a:solidFill>
+                          <a:latin typeface="Arial" pitchFamily="34" charset="0"/>
+                          <a:ea typeface="Arial" pitchFamily="34" charset="-122"/>
+                          <a:cs typeface="Arial" pitchFamily="34" charset="-120"/>
+                        </a:rPr>
+                        <a:t>Verified, booking-gated reviews</a:t>
+                      </a:r>
+                      <a:endParaRPr lang="en-US" sz="1050" dirty="0">
+                        <a:latin typeface="Arial" charset="0"/>
+                        <a:ea typeface="Arial" charset="0"/>
+                        <a:cs typeface="Arial" charset="0"/>
+                      </a:endParaRPr>
+                    </a:p>
+                  </a:txBody>
+                  <a:tcPr marL="91440" marR="91440" marT="45720" marB="45720" anchor="ctr">
+                    <a:lnL w="6350" cap="flat" cmpd="sng" algn="ctr">
+                      <a:solidFill>
+                        <a:srgbClr val="2A2740"/>
+                      </a:solidFill>
+                      <a:prstDash val="solid"/>
+                      <a:round/>
+                      <a:headEnd type="none" w="med" len="med"/>
+                      <a:tailEnd type="none" w="med" len="med"/>
+                    </a:lnL>
+                    <a:lnR w="6350" cap="flat" cmpd="sng" algn="ctr">
+                      <a:solidFill>
+                        <a:srgbClr val="2A2740"/>
+                      </a:solidFill>
+                      <a:prstDash val="solid"/>
+                      <a:round/>
+                      <a:headEnd type="none" w="med" len="med"/>
+                      <a:tailEnd type="none" w="med" len="med"/>
+                    </a:lnR>
+                    <a:lnT w="6350" cap="flat" cmpd="sng" algn="ctr">
+                      <a:solidFill>
+                        <a:srgbClr val="2A2740"/>
+                      </a:solidFill>
+                      <a:prstDash val="solid"/>
+                      <a:round/>
+                      <a:headEnd type="none" w="med" len="med"/>
+                      <a:tailEnd type="none" w="med" len="med"/>
+                    </a:lnT>
+                    <a:lnB w="6350" cap="flat" cmpd="sng" algn="ctr">
+                      <a:solidFill>
+                        <a:srgbClr val="2A2740"/>
+                      </a:solidFill>
+                      <a:prstDash val="solid"/>
+                      <a:round/>
+                      <a:headEnd type="none" w="med" len="med"/>
+                      <a:tailEnd type="none" w="med" len="med"/>
+                    </a:lnB>
+                    <a:solidFill>
+                      <a:srgbClr val="15131F"/>
+                    </a:solidFill>
+                  </a:tcPr>
+                </a:tc>
+                <a:tc>
+                  <a:txBody>
+                    <a:bodyPr/>
+                    <a:lstStyle/>
+                    <a:p>
+                      <a:pPr algn="ctr" indent="0" marL="0">
+                        <a:buNone/>
+                      </a:pPr>
+                      <a:r>
+                        <a:rPr lang="en-US" sz="1050" b="1" dirty="0">
+                          <a:solidFill>
+                            <a:srgbClr val="FBBF24"/>
+                          </a:solidFill>
+                          <a:latin typeface="Arial" pitchFamily="34" charset="0"/>
+                          <a:ea typeface="Arial" pitchFamily="34" charset="-122"/>
+                          <a:cs typeface="Arial" pitchFamily="34" charset="-120"/>
+                        </a:rPr>
+                        <a:t>~</a:t>
+                      </a:r>
+                      <a:endParaRPr lang="en-US" sz="1050" dirty="0">
+                        <a:latin typeface="Arial" charset="0"/>
+                        <a:ea typeface="Arial" charset="0"/>
+                        <a:cs typeface="Arial" charset="0"/>
+                      </a:endParaRPr>
+                    </a:p>
+                  </a:txBody>
+                  <a:tcPr marL="91440" marR="91440" marT="45720" marB="45720" anchor="ctr">
+                    <a:lnL w="6350" cap="flat" cmpd="sng" algn="ctr">
+                      <a:solidFill>
+                        <a:srgbClr val="2A2740"/>
+                      </a:solidFill>
+                      <a:prstDash val="solid"/>
+                      <a:round/>
+                      <a:headEnd type="none" w="med" len="med"/>
+                      <a:tailEnd type="none" w="med" len="med"/>
+                    </a:lnL>
+                    <a:lnR w="6350" cap="flat" cmpd="sng" algn="ctr">
+                      <a:solidFill>
+                        <a:srgbClr val="2A2740"/>
+                      </a:solidFill>
+                      <a:prstDash val="solid"/>
+                      <a:round/>
+                      <a:headEnd type="none" w="med" len="med"/>
+                      <a:tailEnd type="none" w="med" len="med"/>
+                    </a:lnR>
+                    <a:lnT w="6350" cap="flat" cmpd="sng" algn="ctr">
+                      <a:solidFill>
+                        <a:srgbClr val="2A2740"/>
+                      </a:solidFill>
+                      <a:prstDash val="solid"/>
+                      <a:round/>
+                      <a:headEnd type="none" w="med" len="med"/>
+                      <a:tailEnd type="none" w="med" len="med"/>
+                    </a:lnT>
+                    <a:lnB w="6350" cap="flat" cmpd="sng" algn="ctr">
+                      <a:solidFill>
+                        <a:srgbClr val="2A2740"/>
+                      </a:solidFill>
+                      <a:prstDash val="solid"/>
+                      <a:round/>
+                      <a:headEnd type="none" w="med" len="med"/>
+                      <a:tailEnd type="none" w="med" len="med"/>
+                    </a:lnB>
+                    <a:solidFill>
+                      <a:srgbClr val="15131F"/>
+                    </a:solidFill>
+                  </a:tcPr>
+                </a:tc>
+                <a:tc>
+                  <a:txBody>
+                    <a:bodyPr/>
+                    <a:lstStyle/>
+                    <a:p>
+                      <a:pPr algn="ctr" indent="0" marL="0">
+                        <a:buNone/>
+                      </a:pPr>
+                      <a:r>
+                        <a:rPr lang="en-US" sz="1050" b="1" dirty="0">
+                          <a:solidFill>
+                            <a:srgbClr val="FB7185"/>
+                          </a:solidFill>
+                          <a:latin typeface="Arial" pitchFamily="34" charset="0"/>
+                          <a:ea typeface="Arial" pitchFamily="34" charset="-122"/>
+                          <a:cs typeface="Arial" pitchFamily="34" charset="-120"/>
+                        </a:rPr>
+                        <a:t>✗</a:t>
+                      </a:r>
+                      <a:endParaRPr lang="en-US" sz="1050" dirty="0">
+                        <a:latin typeface="Arial" charset="0"/>
+                        <a:ea typeface="Arial" charset="0"/>
+                        <a:cs typeface="Arial" charset="0"/>
+                      </a:endParaRPr>
+                    </a:p>
+                  </a:txBody>
+                  <a:tcPr marL="91440" marR="91440" marT="45720" marB="45720" anchor="ctr">
+                    <a:lnL w="6350" cap="flat" cmpd="sng" algn="ctr">
+                      <a:solidFill>
+                        <a:srgbClr val="2A2740"/>
+                      </a:solidFill>
+                      <a:prstDash val="solid"/>
+                      <a:round/>
+                      <a:headEnd type="none" w="med" len="med"/>
+                      <a:tailEnd type="none" w="med" len="med"/>
+                    </a:lnL>
+                    <a:lnR w="6350" cap="flat" cmpd="sng" algn="ctr">
+                      <a:solidFill>
+                        <a:srgbClr val="2A2740"/>
+                      </a:solidFill>
+                      <a:prstDash val="solid"/>
+                      <a:round/>
+                      <a:headEnd type="none" w="med" len="med"/>
+                      <a:tailEnd type="none" w="med" len="med"/>
+                    </a:lnR>
+                    <a:lnT w="6350" cap="flat" cmpd="sng" algn="ctr">
+                      <a:solidFill>
+                        <a:srgbClr val="2A2740"/>
+                      </a:solidFill>
+                      <a:prstDash val="solid"/>
+                      <a:round/>
+                      <a:headEnd type="none" w="med" len="med"/>
+                      <a:tailEnd type="none" w="med" len="med"/>
+                    </a:lnT>
+                    <a:lnB w="6350" cap="flat" cmpd="sng" algn="ctr">
+                      <a:solidFill>
+                        <a:srgbClr val="2A2740"/>
+                      </a:solidFill>
+                      <a:prstDash val="solid"/>
+                      <a:round/>
+                      <a:headEnd type="none" w="med" len="med"/>
+                      <a:tailEnd type="none" w="med" len="med"/>
+                    </a:lnB>
+                    <a:solidFill>
+                      <a:srgbClr val="15131F"/>
+                    </a:solidFill>
+                  </a:tcPr>
+                </a:tc>
+                <a:tc>
+                  <a:txBody>
+                    <a:bodyPr/>
+                    <a:lstStyle/>
+                    <a:p>
+                      <a:pPr algn="ctr" indent="0" marL="0">
+                        <a:buNone/>
+                      </a:pPr>
+                      <a:r>
+                        <a:rPr lang="en-US" sz="1050" b="1" dirty="0">
+                          <a:solidFill>
+                            <a:srgbClr val="34D399"/>
+                          </a:solidFill>
+                          <a:latin typeface="Arial" pitchFamily="34" charset="0"/>
+                          <a:ea typeface="Arial" pitchFamily="34" charset="-122"/>
+                          <a:cs typeface="Arial" pitchFamily="34" charset="-120"/>
+                        </a:rPr>
+                        <a:t>✓</a:t>
+                      </a:r>
+                      <a:endParaRPr lang="en-US" sz="1050" dirty="0">
+                        <a:latin typeface="Arial" charset="0"/>
+                        <a:ea typeface="Arial" charset="0"/>
+                        <a:cs typeface="Arial" charset="0"/>
+                      </a:endParaRPr>
+                    </a:p>
+                  </a:txBody>
+                  <a:tcPr marL="91440" marR="91440" marT="45720" marB="45720" anchor="ctr">
+                    <a:lnL w="6350" cap="flat" cmpd="sng" algn="ctr">
+                      <a:solidFill>
+                        <a:srgbClr val="2A2740"/>
+                      </a:solidFill>
+                      <a:prstDash val="solid"/>
+                      <a:round/>
+                      <a:headEnd type="none" w="med" len="med"/>
+                      <a:tailEnd type="none" w="med" len="med"/>
+                    </a:lnL>
+                    <a:lnR w="6350" cap="flat" cmpd="sng" algn="ctr">
+                      <a:solidFill>
+                        <a:srgbClr val="2A2740"/>
+                      </a:solidFill>
+                      <a:prstDash val="solid"/>
+                      <a:round/>
+                      <a:headEnd type="none" w="med" len="med"/>
+                      <a:tailEnd type="none" w="med" len="med"/>
+                    </a:lnR>
+                    <a:lnT w="6350" cap="flat" cmpd="sng" algn="ctr">
+                      <a:solidFill>
+                        <a:srgbClr val="2A2740"/>
+                      </a:solidFill>
+                      <a:prstDash val="solid"/>
+                      <a:round/>
+                      <a:headEnd type="none" w="med" len="med"/>
+                      <a:tailEnd type="none" w="med" len="med"/>
+                    </a:lnT>
+                    <a:lnB w="6350" cap="flat" cmpd="sng" algn="ctr">
+                      <a:solidFill>
+                        <a:srgbClr val="2A2740"/>
+                      </a:solidFill>
+                      <a:prstDash val="solid"/>
+                      <a:round/>
+                      <a:headEnd type="none" w="med" len="med"/>
+                      <a:tailEnd type="none" w="med" len="med"/>
+                    </a:lnB>
+                    <a:solidFill>
+                      <a:srgbClr val="20143A"/>
+                    </a:solidFill>
+                  </a:tcPr>
+                </a:tc>
+              </a:tr>
+              <a:tr h="324612">
+                <a:tc>
+                  <a:txBody>
+                    <a:bodyPr/>
+                    <a:lstStyle/>
+                    <a:p>
+                      <a:pPr algn="l" indent="0" marL="0">
+                        <a:buNone/>
+                      </a:pPr>
+                      <a:r>
+                        <a:rPr lang="en-US" sz="1050" dirty="0">
+                          <a:solidFill>
+                            <a:srgbClr val="E8E8F0"/>
+                          </a:solidFill>
+                          <a:latin typeface="Arial" pitchFamily="34" charset="0"/>
+                          <a:ea typeface="Arial" pitchFamily="34" charset="-122"/>
+                          <a:cs typeface="Arial" pitchFamily="34" charset="-120"/>
+                        </a:rPr>
+                        <a:t>AI assistant + EV / amenity filters</a:t>
+                      </a:r>
+                      <a:endParaRPr lang="en-US" sz="1050" dirty="0">
+                        <a:latin typeface="Arial" charset="0"/>
+                        <a:ea typeface="Arial" charset="0"/>
+                        <a:cs typeface="Arial" charset="0"/>
+                      </a:endParaRPr>
+                    </a:p>
+                  </a:txBody>
+                  <a:tcPr marL="91440" marR="91440" marT="45720" marB="45720" anchor="ctr">
+                    <a:lnL w="6350" cap="flat" cmpd="sng" algn="ctr">
+                      <a:solidFill>
+                        <a:srgbClr val="2A2740"/>
+                      </a:solidFill>
+                      <a:prstDash val="solid"/>
+                      <a:round/>
+                      <a:headEnd type="none" w="med" len="med"/>
+                      <a:tailEnd type="none" w="med" len="med"/>
+                    </a:lnL>
+                    <a:lnR w="6350" cap="flat" cmpd="sng" algn="ctr">
+                      <a:solidFill>
+                        <a:srgbClr val="2A2740"/>
+                      </a:solidFill>
+                      <a:prstDash val="solid"/>
+                      <a:round/>
+                      <a:headEnd type="none" w="med" len="med"/>
+                      <a:tailEnd type="none" w="med" len="med"/>
+                    </a:lnR>
+                    <a:lnT w="6350" cap="flat" cmpd="sng" algn="ctr">
+                      <a:solidFill>
+                        <a:srgbClr val="2A2740"/>
+                      </a:solidFill>
+                      <a:prstDash val="solid"/>
+                      <a:round/>
+                      <a:headEnd type="none" w="med" len="med"/>
+                      <a:tailEnd type="none" w="med" len="med"/>
+                    </a:lnT>
+                    <a:lnB w="6350" cap="flat" cmpd="sng" algn="ctr">
+                      <a:solidFill>
+                        <a:srgbClr val="2A2740"/>
+                      </a:solidFill>
+                      <a:prstDash val="solid"/>
+                      <a:round/>
+                      <a:headEnd type="none" w="med" len="med"/>
+                      <a:tailEnd type="none" w="med" len="med"/>
+                    </a:lnB>
+                    <a:solidFill>
+                      <a:srgbClr val="15131F"/>
+                    </a:solidFill>
+                  </a:tcPr>
+                </a:tc>
+                <a:tc>
+                  <a:txBody>
+                    <a:bodyPr/>
+                    <a:lstStyle/>
+                    <a:p>
+                      <a:pPr algn="ctr" indent="0" marL="0">
+                        <a:buNone/>
+                      </a:pPr>
+                      <a:r>
+                        <a:rPr lang="en-US" sz="1050" b="1" dirty="0">
+                          <a:solidFill>
+                            <a:srgbClr val="FBBF24"/>
+                          </a:solidFill>
+                          <a:latin typeface="Arial" pitchFamily="34" charset="0"/>
+                          <a:ea typeface="Arial" pitchFamily="34" charset="-122"/>
+                          <a:cs typeface="Arial" pitchFamily="34" charset="-120"/>
+                        </a:rPr>
+                        <a:t>~</a:t>
+                      </a:r>
+                      <a:endParaRPr lang="en-US" sz="1050" dirty="0">
+                        <a:latin typeface="Arial" charset="0"/>
+                        <a:ea typeface="Arial" charset="0"/>
+                        <a:cs typeface="Arial" charset="0"/>
+                      </a:endParaRPr>
+                    </a:p>
+                  </a:txBody>
+                  <a:tcPr marL="91440" marR="91440" marT="45720" marB="45720" anchor="ctr">
+                    <a:lnL w="6350" cap="flat" cmpd="sng" algn="ctr">
+                      <a:solidFill>
+                        <a:srgbClr val="2A2740"/>
+                      </a:solidFill>
+                      <a:prstDash val="solid"/>
+                      <a:round/>
+                      <a:headEnd type="none" w="med" len="med"/>
+                      <a:tailEnd type="none" w="med" len="med"/>
+                    </a:lnL>
+                    <a:lnR w="6350" cap="flat" cmpd="sng" algn="ctr">
+                      <a:solidFill>
+                        <a:srgbClr val="2A2740"/>
+                      </a:solidFill>
+                      <a:prstDash val="solid"/>
+                      <a:round/>
+                      <a:headEnd type="none" w="med" len="med"/>
+                      <a:tailEnd type="none" w="med" len="med"/>
+                    </a:lnR>
+                    <a:lnT w="6350" cap="flat" cmpd="sng" algn="ctr">
+                      <a:solidFill>
+                        <a:srgbClr val="2A2740"/>
+                      </a:solidFill>
+                      <a:prstDash val="solid"/>
+                      <a:round/>
+                      <a:headEnd type="none" w="med" len="med"/>
+                      <a:tailEnd type="none" w="med" len="med"/>
+                    </a:lnT>
+                    <a:lnB w="6350" cap="flat" cmpd="sng" algn="ctr">
+                      <a:solidFill>
+                        <a:srgbClr val="2A2740"/>
+                      </a:solidFill>
+                      <a:prstDash val="solid"/>
+                      <a:round/>
+                      <a:headEnd type="none" w="med" len="med"/>
+                      <a:tailEnd type="none" w="med" len="med"/>
+                    </a:lnB>
+                    <a:solidFill>
+                      <a:srgbClr val="15131F"/>
+                    </a:solidFill>
+                  </a:tcPr>
+                </a:tc>
+                <a:tc>
+                  <a:txBody>
+                    <a:bodyPr/>
+                    <a:lstStyle/>
+                    <a:p>
+                      <a:pPr algn="ctr" indent="0" marL="0">
+                        <a:buNone/>
+                      </a:pPr>
+                      <a:r>
+                        <a:rPr lang="en-US" sz="1050" b="1" dirty="0">
+                          <a:solidFill>
+                            <a:srgbClr val="FB7185"/>
+                          </a:solidFill>
+                          <a:latin typeface="Arial" pitchFamily="34" charset="0"/>
+                          <a:ea typeface="Arial" pitchFamily="34" charset="-122"/>
+                          <a:cs typeface="Arial" pitchFamily="34" charset="-120"/>
+                        </a:rPr>
+                        <a:t>✗</a:t>
+                      </a:r>
+                      <a:endParaRPr lang="en-US" sz="1050" dirty="0">
+                        <a:latin typeface="Arial" charset="0"/>
+                        <a:ea typeface="Arial" charset="0"/>
+                        <a:cs typeface="Arial" charset="0"/>
+                      </a:endParaRPr>
+                    </a:p>
+                  </a:txBody>
+                  <a:tcPr marL="91440" marR="91440" marT="45720" marB="45720" anchor="ctr">
+                    <a:lnL w="6350" cap="flat" cmpd="sng" algn="ctr">
+                      <a:solidFill>
+                        <a:srgbClr val="2A2740"/>
+                      </a:solidFill>
+                      <a:prstDash val="solid"/>
+                      <a:round/>
+                      <a:headEnd type="none" w="med" len="med"/>
+                      <a:tailEnd type="none" w="med" len="med"/>
+                    </a:lnL>
+                    <a:lnR w="6350" cap="flat" cmpd="sng" algn="ctr">
+                      <a:solidFill>
+                        <a:srgbClr val="2A2740"/>
+                      </a:solidFill>
+                      <a:prstDash val="solid"/>
+                      <a:round/>
+                      <a:headEnd type="none" w="med" len="med"/>
+                      <a:tailEnd type="none" w="med" len="med"/>
+                    </a:lnR>
+                    <a:lnT w="6350" cap="flat" cmpd="sng" algn="ctr">
+                      <a:solidFill>
+                        <a:srgbClr val="2A2740"/>
+                      </a:solidFill>
+                      <a:prstDash val="solid"/>
+                      <a:round/>
+                      <a:headEnd type="none" w="med" len="med"/>
+                      <a:tailEnd type="none" w="med" len="med"/>
+                    </a:lnT>
+                    <a:lnB w="6350" cap="flat" cmpd="sng" algn="ctr">
+                      <a:solidFill>
+                        <a:srgbClr val="2A2740"/>
+                      </a:solidFill>
+                      <a:prstDash val="solid"/>
+                      <a:round/>
+                      <a:headEnd type="none" w="med" len="med"/>
+                      <a:tailEnd type="none" w="med" len="med"/>
+                    </a:lnB>
+                    <a:solidFill>
+                      <a:srgbClr val="15131F"/>
+                    </a:solidFill>
+                  </a:tcPr>
+                </a:tc>
+                <a:tc>
+                  <a:txBody>
+                    <a:bodyPr/>
+                    <a:lstStyle/>
+                    <a:p>
+                      <a:pPr algn="ctr" indent="0" marL="0">
+                        <a:buNone/>
+                      </a:pPr>
+                      <a:r>
+                        <a:rPr lang="en-US" sz="1050" b="1" dirty="0">
+                          <a:solidFill>
+                            <a:srgbClr val="34D399"/>
+                          </a:solidFill>
+                          <a:latin typeface="Arial" pitchFamily="34" charset="0"/>
+                          <a:ea typeface="Arial" pitchFamily="34" charset="-122"/>
+                          <a:cs typeface="Arial" pitchFamily="34" charset="-120"/>
+                        </a:rPr>
+                        <a:t>✓</a:t>
+                      </a:r>
+                      <a:endParaRPr lang="en-US" sz="1050" dirty="0">
+                        <a:latin typeface="Arial" charset="0"/>
+                        <a:ea typeface="Arial" charset="0"/>
+                        <a:cs typeface="Arial" charset="0"/>
+                      </a:endParaRPr>
+                    </a:p>
+                  </a:txBody>
+                  <a:tcPr marL="91440" marR="91440" marT="45720" marB="45720" anchor="ctr">
+                    <a:lnL w="6350" cap="flat" cmpd="sng" algn="ctr">
+                      <a:solidFill>
+                        <a:srgbClr val="2A2740"/>
+                      </a:solidFill>
+                      <a:prstDash val="solid"/>
+                      <a:round/>
+                      <a:headEnd type="none" w="med" len="med"/>
+                      <a:tailEnd type="none" w="med" len="med"/>
+                    </a:lnL>
+                    <a:lnR w="6350" cap="flat" cmpd="sng" algn="ctr">
+                      <a:solidFill>
+                        <a:srgbClr val="2A2740"/>
+                      </a:solidFill>
+                      <a:prstDash val="solid"/>
+                      <a:round/>
+                      <a:headEnd type="none" w="med" len="med"/>
+                      <a:tailEnd type="none" w="med" len="med"/>
+                    </a:lnR>
+                    <a:lnT w="6350" cap="flat" cmpd="sng" algn="ctr">
+                      <a:solidFill>
+                        <a:srgbClr val="2A2740"/>
+                      </a:solidFill>
+                      <a:prstDash val="solid"/>
+                      <a:round/>
+                      <a:headEnd type="none" w="med" len="med"/>
+                      <a:tailEnd type="none" w="med" len="med"/>
+                    </a:lnT>
+                    <a:lnB w="6350" cap="flat" cmpd="sng" algn="ctr">
+                      <a:solidFill>
+                        <a:srgbClr val="2A2740"/>
+                      </a:solidFill>
+                      <a:prstDash val="solid"/>
+                      <a:round/>
+                      <a:headEnd type="none" w="med" len="med"/>
+                      <a:tailEnd type="none" w="med" len="med"/>
+                    </a:lnB>
+                    <a:solidFill>
+                      <a:srgbClr val="20143A"/>
+                    </a:solidFill>
+                  </a:tcPr>
+                </a:tc>
+              </a:tr>
+            </a:tbl>
+          </a:graphicData>
+        </a:graphic>
+      </p:graphicFrame>
     </p:spTree>
   </p:cSld>
   <p:clrMapOvr>
@@ -4124,6 +6600,296 @@
 <file path=ppt/slides/slide13.xml><?xml version="1.0" encoding="utf-8"?>
 <p:sld xmlns:a="http://schemas.openxmlformats.org/drawingml/2006/main" xmlns:r="http://schemas.openxmlformats.org/officeDocument/2006/relationships" xmlns:p="http://schemas.openxmlformats.org/presentationml/2006/main">
   <p:cSld name="Slide 13">
+    <p:bg>
+      <p:bgPr>
+        <a:solidFill>
+          <a:srgbClr val="0A0A12"/>
+        </a:solidFill>
+      </p:bgPr>
+    </p:bg>
+    <p:spTree>
+      <p:nvGrpSpPr>
+        <p:cNvPr id="1" name=""/>
+        <p:cNvGrpSpPr/>
+        <p:nvPr/>
+      </p:nvGrpSpPr>
+      <p:grpSpPr>
+        <a:xfrm>
+          <a:off x="0" y="0"/>
+          <a:ext cx="0" cy="0"/>
+          <a:chOff x="0" y="0"/>
+          <a:chExt cx="0" cy="0"/>
+        </a:xfrm>
+      </p:grpSpPr>
+      <p:sp>
+        <p:nvSpPr>
+          <p:cNvPr id="2" name="Text 0"/>
+          <p:cNvSpPr/>
+          <p:nvPr/>
+        </p:nvSpPr>
+        <p:spPr>
+          <a:xfrm>
+            <a:off x="507950" y="905024"/>
+            <a:ext cx="8290661" cy="152400"/>
+          </a:xfrm>
+          <a:prstGeom prst="rect">
+            <a:avLst/>
+          </a:prstGeom>
+          <a:noFill/>
+          <a:ln/>
+        </p:spPr>
+        <p:txBody>
+          <a:bodyPr wrap="square" lIns="0" tIns="0" rIns="0" bIns="0" rtlCol="0" anchor="t"/>
+          <a:lstStyle/>
+          <a:p>
+            <a:pPr algn="l" indent="0" marL="0">
+              <a:buNone/>
+            </a:pPr>
+            <a:r>
+              <a:rPr lang="en-US" sz="1100" b="1" dirty="0">
+                <a:solidFill>
+                  <a:srgbClr val="C084FC"/>
+                </a:solidFill>
+                <a:latin typeface="Arial" pitchFamily="34" charset="0"/>
+                <a:ea typeface="Arial" pitchFamily="34" charset="-122"/>
+                <a:cs typeface="Arial" pitchFamily="34" charset="-120"/>
+              </a:rPr>
+              <a:t>THE VISION</a:t>
+            </a:r>
+            <a:endParaRPr lang="en-US" sz="1100" dirty="0"/>
+          </a:p>
+        </p:txBody>
+      </p:sp>
+      <p:sp>
+        <p:nvSpPr>
+          <p:cNvPr id="3" name="Text 1"/>
+          <p:cNvSpPr/>
+          <p:nvPr/>
+        </p:nvSpPr>
+        <p:spPr>
+          <a:xfrm>
+            <a:off x="507950" y="1209824"/>
+            <a:ext cx="8290661" cy="1168003"/>
+          </a:xfrm>
+          <a:prstGeom prst="rect">
+            <a:avLst/>
+          </a:prstGeom>
+          <a:noFill/>
+          <a:ln/>
+        </p:spPr>
+        <p:txBody>
+          <a:bodyPr wrap="square" lIns="0" tIns="0" rIns="0" bIns="0" rtlCol="0" anchor="t"/>
+          <a:lstStyle/>
+          <a:p>
+            <a:pPr algn="l" indent="0" marL="0">
+              <a:lnSpc>
+                <a:spcPts val="4600"/>
+              </a:lnSpc>
+              <a:spcBef>
+                <a:spcPts val="1200"/>
+              </a:spcBef>
+              <a:buNone/>
+            </a:pPr>
+            <a:r>
+              <a:rPr lang="en-US" sz="4000" dirty="0">
+                <a:solidFill>
+                  <a:srgbClr val="FFFFFF"/>
+                </a:solidFill>
+                <a:latin typeface="Arial" pitchFamily="34" charset="0"/>
+                <a:ea typeface="Arial" pitchFamily="34" charset="-122"/>
+                <a:cs typeface="Arial" pitchFamily="34" charset="-120"/>
+              </a:rPr>
+              <a:t>Park with certainty.
+</a:t>
+            </a:r>
+            <a:pPr algn="l" indent="0" marL="0">
+              <a:lnSpc>
+                <a:spcPts val="4600"/>
+              </a:lnSpc>
+              <a:spcBef>
+                <a:spcPts val="1200"/>
+              </a:spcBef>
+              <a:buNone/>
+            </a:pPr>
+            <a:r>
+              <a:rPr lang="en-US" sz="4000" b="1" dirty="0">
+                <a:solidFill>
+                  <a:srgbClr val="C084FC"/>
+                </a:solidFill>
+                <a:latin typeface="Arial" pitchFamily="34" charset="0"/>
+                <a:ea typeface="Arial" pitchFamily="34" charset="-122"/>
+                <a:cs typeface="Arial" pitchFamily="34" charset="-120"/>
+              </a:rPr>
+              <a:t>Arrive with ease.</a:t>
+            </a:r>
+            <a:endParaRPr lang="en-US" sz="4000" dirty="0"/>
+          </a:p>
+        </p:txBody>
+      </p:sp>
+      <p:pic>
+        <p:nvPicPr>
+          <p:cNvPr id="4" name="Image 0" descr="/Users/yashwantyadav/Desktop/Parking_assist/deck-build/assets/gradbar.png">    </p:cNvPr>
+          <p:cNvPicPr>
+            <a:picLocks noChangeAspect="1"/>
+          </p:cNvPicPr>
+          <p:nvPr/>
+        </p:nvPicPr>
+        <p:blipFill>
+          <a:blip r:embed="rId1"/>
+          <a:stretch>
+            <a:fillRect/>
+          </a:stretch>
+        </p:blipFill>
+        <p:spPr>
+          <a:xfrm>
+            <a:off x="507950" y="2580977"/>
+            <a:ext cx="1905000" cy="76200"/>
+          </a:xfrm>
+          <a:prstGeom prst="rect">
+            <a:avLst/>
+          </a:prstGeom>
+        </p:spPr>
+      </p:pic>
+      <p:sp>
+        <p:nvSpPr>
+          <p:cNvPr id="5" name="Text 2"/>
+          <p:cNvSpPr/>
+          <p:nvPr/>
+        </p:nvSpPr>
+        <p:spPr>
+          <a:xfrm>
+            <a:off x="507950" y="2885777"/>
+            <a:ext cx="7254139" cy="533400"/>
+          </a:xfrm>
+          <a:prstGeom prst="rect">
+            <a:avLst/>
+          </a:prstGeom>
+          <a:noFill/>
+          <a:ln/>
+        </p:spPr>
+        <p:txBody>
+          <a:bodyPr wrap="square" lIns="0" tIns="0" rIns="0" bIns="0" rtlCol="0" anchor="t"/>
+          <a:lstStyle/>
+          <a:p>
+            <a:pPr algn="l" indent="0" marL="0">
+              <a:lnSpc>
+                <a:spcPts val="2100"/>
+              </a:lnSpc>
+              <a:spcBef>
+                <a:spcPts val="1800"/>
+              </a:spcBef>
+              <a:buNone/>
+            </a:pPr>
+            <a:r>
+              <a:rPr lang="en-US" sz="1400" dirty="0">
+                <a:solidFill>
+                  <a:srgbClr val="C6C8D4"/>
+                </a:solidFill>
+                <a:latin typeface="Arial" pitchFamily="34" charset="0"/>
+                <a:ea typeface="Arial" pitchFamily="34" charset="-122"/>
+                <a:cs typeface="Arial" pitchFamily="34" charset="-120"/>
+              </a:rPr>
+              <a:t>ParkEase turns wasted minutes and avoidable fines into a single tap — making India’s cities move a little more smoothly.</a:t>
+            </a:r>
+            <a:endParaRPr lang="en-US" sz="1400" dirty="0"/>
+          </a:p>
+        </p:txBody>
+      </p:sp>
+      <p:sp>
+        <p:nvSpPr>
+          <p:cNvPr id="6" name="Text 3"/>
+          <p:cNvSpPr/>
+          <p:nvPr/>
+        </p:nvSpPr>
+        <p:spPr>
+          <a:xfrm>
+            <a:off x="507950" y="3723977"/>
+            <a:ext cx="8290661" cy="171450"/>
+          </a:xfrm>
+          <a:prstGeom prst="rect">
+            <a:avLst/>
+          </a:prstGeom>
+          <a:noFill/>
+          <a:ln/>
+        </p:spPr>
+        <p:txBody>
+          <a:bodyPr wrap="square" lIns="0" tIns="0" rIns="0" bIns="0" rtlCol="0" anchor="t"/>
+          <a:lstStyle/>
+          <a:p>
+            <a:pPr algn="l" indent="0" marL="0">
+              <a:spcBef>
+                <a:spcPts val="2400"/>
+              </a:spcBef>
+              <a:buNone/>
+            </a:pPr>
+            <a:r>
+              <a:rPr lang="en-US" sz="1200" dirty="0">
+                <a:solidFill>
+                  <a:srgbClr val="8B8FA6"/>
+                </a:solidFill>
+                <a:latin typeface="Arial" pitchFamily="34" charset="0"/>
+                <a:ea typeface="Arial" pitchFamily="34" charset="-122"/>
+                <a:cs typeface="Arial" pitchFamily="34" charset="-120"/>
+              </a:rPr>
+              <a:t>Thank you.   Let’s build the future of parking.</a:t>
+            </a:r>
+            <a:endParaRPr lang="en-US" sz="1200" dirty="0"/>
+          </a:p>
+        </p:txBody>
+      </p:sp>
+      <p:sp>
+        <p:nvSpPr>
+          <p:cNvPr id="7" name="Text 4"/>
+          <p:cNvSpPr/>
+          <p:nvPr/>
+        </p:nvSpPr>
+        <p:spPr>
+          <a:xfrm>
+            <a:off x="507950" y="4124027"/>
+            <a:ext cx="8290661" cy="114300"/>
+          </a:xfrm>
+          <a:prstGeom prst="rect">
+            <a:avLst/>
+          </a:prstGeom>
+          <a:noFill/>
+          <a:ln/>
+        </p:spPr>
+        <p:txBody>
+          <a:bodyPr wrap="square" lIns="0" tIns="0" rIns="0" bIns="0" rtlCol="0" anchor="t"/>
+          <a:lstStyle/>
+          <a:p>
+            <a:pPr algn="l" indent="0" marL="0">
+              <a:spcBef>
+                <a:spcPts val="1800"/>
+              </a:spcBef>
+              <a:buNone/>
+            </a:pPr>
+            <a:r>
+              <a:rPr lang="en-US" sz="800" dirty="0">
+                <a:solidFill>
+                  <a:srgbClr val="5B5F73"/>
+                </a:solidFill>
+                <a:latin typeface="Arial" pitchFamily="34" charset="0"/>
+                <a:ea typeface="Arial" pitchFamily="34" charset="-122"/>
+                <a:cs typeface="Arial" pitchFamily="34" charset="-120"/>
+              </a:rPr>
+              <a:t>All statistics are reported/illustrative figures included for discussion; verify and cite primary sources before any public or investor use.</a:t>
+            </a:r>
+            <a:endParaRPr lang="en-US" sz="800" dirty="0"/>
+          </a:p>
+        </p:txBody>
+      </p:sp>
+    </p:spTree>
+  </p:cSld>
+  <p:clrMapOvr>
+    <a:masterClrMapping/>
+  </p:clrMapOvr>
+</p:sld>
+</file>
+
+<file path=ppt/slides/slide14.xml><?xml version="1.0" encoding="utf-8"?>
+<p:sld xmlns:a="http://schemas.openxmlformats.org/drawingml/2006/main" xmlns:r="http://schemas.openxmlformats.org/officeDocument/2006/relationships" xmlns:p="http://schemas.openxmlformats.org/presentationml/2006/main">
+  <p:cSld name="Slide 14">
     <p:bg>
       <p:bgPr>
         <a:solidFill>

</xml_diff>